<commit_message>
M20: Sim-Review umgesetzt (sim_review true, Inhalt aktualisiert)
Co-Authored-By: Claude Opus 4.8 <noreply@anthropic.com>
</commit_message>
<xml_diff>
--- a/protected-downloads/praesentation/M20.pptx
+++ b/protected-downloads/praesentation/M20.pptx
@@ -9644,7 +9644,7 @@
                 </a:solidFill>
                 <a:latin typeface="Consolas"/>
               </a:rPr>
-              <a:t>00:28       </a:t>
+              <a:t>00:30       </a:t>
             </a:r>
             <a:r>
               <a:rPr sz="1200" b="1">
@@ -9681,7 +9681,7 @@
                 </a:solidFill>
                 <a:latin typeface="Consolas"/>
               </a:rPr>
-              <a:t>00:43       </a:t>
+              <a:t>00:45       </a:t>
             </a:r>
             <a:r>
               <a:rPr sz="1200" b="1">
@@ -9718,7 +9718,7 @@
                 </a:solidFill>
                 <a:latin typeface="Consolas"/>
               </a:rPr>
-              <a:t>00:50       </a:t>
+              <a:t>00:55       </a:t>
             </a:r>
             <a:r>
               <a:rPr sz="1200" b="1">
@@ -9755,7 +9755,7 @@
                 </a:solidFill>
                 <a:latin typeface="Consolas"/>
               </a:rPr>
-              <a:t>01:00       </a:t>
+              <a:t>01:05       </a:t>
             </a:r>
             <a:r>
               <a:rPr sz="1200" b="1">
@@ -9792,7 +9792,7 @@
                 </a:solidFill>
                 <a:latin typeface="Consolas"/>
               </a:rPr>
-              <a:t>01:12       </a:t>
+              <a:t>01:17       </a:t>
             </a:r>
             <a:r>
               <a:rPr sz="1200" b="1">
@@ -9829,7 +9829,7 @@
                 </a:solidFill>
                 <a:latin typeface="Consolas"/>
               </a:rPr>
-              <a:t>01:20       </a:t>
+              <a:t>01:25       </a:t>
             </a:r>
             <a:r>
               <a:rPr sz="1200" b="1">
@@ -9866,7 +9866,7 @@
                 </a:solidFill>
                 <a:latin typeface="Consolas"/>
               </a:rPr>
-              <a:t>01:27       </a:t>
+              <a:t>01:35       </a:t>
             </a:r>
             <a:r>
               <a:rPr sz="1200" b="1">
@@ -9903,7 +9903,7 @@
                 </a:solidFill>
                 <a:latin typeface="Consolas"/>
               </a:rPr>
-              <a:t>01:30       </a:t>
+              <a:t>01:40       </a:t>
             </a:r>
             <a:r>
               <a:rPr sz="1200" b="1">

</xml_diff>

<commit_message>
M-Track Batch 2: M20 Deck (Web/Workbook)
Co-Authored-By: Claude Fable 5 <noreply@anthropic.com>
</commit_message>
<xml_diff>
--- a/protected-downloads/praesentation/M20.pptx
+++ b/protected-downloads/praesentation/M20.pptx
@@ -19,8 +19,6 @@
     <p:sldId id="267" r:id="rId19"/>
     <p:sldId id="268" r:id="rId20"/>
     <p:sldId id="269" r:id="rId21"/>
-    <p:sldId id="270" r:id="rId22"/>
-    <p:sldId id="271" r:id="rId23"/>
   </p:sldIdLst>
   <p:sldSz cx="12188952" cy="6858000" type="screen4x3"/>
   <p:notesSz cx="6858000" cy="9144000"/>
@@ -542,76 +540,6 @@
 </p:notes>
 </file>
 
-<file path=ppt/notesSlides/notesSlide10.xml><?xml version="1.0" encoding="utf-8"?>
-<p:notes xmlns:a="http://schemas.openxmlformats.org/drawingml/2006/main" xmlns:p="http://schemas.openxmlformats.org/presentationml/2006/main" xmlns:r="http://schemas.openxmlformats.org/officeDocument/2006/relationships">
-  <p:cSld>
-    <p:spTree>
-      <p:nvGrpSpPr>
-        <p:cNvPr id="1" name=""/>
-        <p:cNvGrpSpPr/>
-        <p:nvPr/>
-      </p:nvGrpSpPr>
-      <p:grpSpPr>
-        <a:xfrm>
-          <a:off x="0" y="0"/>
-          <a:ext cx="0" cy="0"/>
-          <a:chOff x="0" y="0"/>
-          <a:chExt cx="0" cy="0"/>
-        </a:xfrm>
-      </p:grpSpPr>
-      <p:sp>
-        <p:nvSpPr>
-          <p:cNvPr id="2" name="Slide Image Placeholder 1"/>
-          <p:cNvSpPr>
-            <a:spLocks noGrp="1"/>
-          </p:cNvSpPr>
-          <p:nvPr>
-            <p:ph type="sldImg" idx="2"/>
-          </p:nvPr>
-        </p:nvSpPr>
-        <p:spPr/>
-      </p:sp>
-      <p:sp>
-        <p:nvSpPr>
-          <p:cNvPr id="3" name="Notes Placeholder 2"/>
-          <p:cNvSpPr>
-            <a:spLocks noGrp="1"/>
-          </p:cNvSpPr>
-          <p:nvPr>
-            <p:ph type="body" idx="3" sz="quarter"/>
-          </p:nvPr>
-        </p:nvSpPr>
-        <p:spPr/>
-        <p:txBody>
-          <a:bodyPr/>
-          <a:lstStyle/>
-          <a:p>
-            <a:r>
-              <a:t>Moderation (HB Sec 3): Kein perfektes Tool nötig – ein leeres A3-Blatt und Stifte reichen Strukturhilfe anbieten: TN zeichnen sich in die Mitte; dann 3 Kreise: enger Kontakt / gelegentlicher Kontakt / Schlafende Verbindungen Häufig unbehagliches Schweigen – das ist produktiv, nicht dramatisch In der Arbeitsanweisung die Spalte „Nächster Schritt" in AB-1 explizit erwähnen: „Füllen Sie auch die letzte Spalte aus – was wäre Ihr nächster Schritt mit diesem Kontakt?" Puffer-Auftrag für Schnellfertige: „Schauen Sie sich Ihre Lückenanalyse auf AB-2 an. Welche drei Personen fehlen in Ihrem Netzwerk – und was wäre Ihr konkreter Anlass für einen ersten Kontakt? Schreiben Sie das unter ‚Nächster Schritt' in AB-1." Das überbrückt die Wartezeit und bereitet den Zweier-Austausch vor.</a:t>
-            </a:r>
-          </a:p>
-        </p:txBody>
-      </p:sp>
-      <p:sp>
-        <p:nvSpPr>
-          <p:cNvPr id="4" name="Slide Number Placeholder 3"/>
-          <p:cNvSpPr>
-            <a:spLocks noGrp="1"/>
-          </p:cNvSpPr>
-          <p:nvPr>
-            <p:ph type="sldNum" idx="5" sz="quarter"/>
-          </p:nvPr>
-        </p:nvSpPr>
-        <p:spPr/>
-      </p:sp>
-    </p:spTree>
-  </p:cSld>
-  <p:clrMapOvr>
-    <a:masterClrMapping/>
-  </p:clrMapOvr>
-</p:notes>
-</file>
-
 <file path=ppt/notesSlides/notesSlide2.xml><?xml version="1.0" encoding="utf-8"?>
 <p:notes xmlns:a="http://schemas.openxmlformats.org/drawingml/2006/main" xmlns:p="http://schemas.openxmlformats.org/presentationml/2006/main" xmlns:r="http://schemas.openxmlformats.org/officeDocument/2006/relationships">
   <p:cSld>
@@ -657,7 +585,7 @@
           <a:lstStyle/>
           <a:p>
             <a:r>
-              <a:t>Siehe Trainerhandbuch (Sektion 3) für Moderationshinweise, Timing und erwartete Teilnehmerreaktionen.</a:t>
+              <a:t>Einstieg: „Wie viele Ihrer letzten drei Neukunden kamen über eine Empfehlung – und wie viele über Kaltakquise?"</a:t>
             </a:r>
           </a:p>
         </p:txBody>
@@ -727,7 +655,7 @@
           <a:lstStyle/>
           <a:p>
             <a:r>
-              <a:t>Siehe Trainerhandbuch (Sektion 3) für Moderationshinweise, Timing und erwartete Teilnehmerreaktionen.</a:t>
+              <a:t>Die drei Dimensionen unterscheiden sich in Pflegeaufwand und Ertrag – das Markt-Netzwerk bringt die Neuanfragen.</a:t>
             </a:r>
           </a:p>
         </p:txBody>
@@ -797,7 +725,7 @@
           <a:lstStyle/>
           <a:p>
             <a:r>
-              <a:t>Siehe Trainerhandbuch (Sektion 3) für Moderationshinweise, Timing und erwartete Teilnehmerreaktionen.</a:t>
+              <a:t>Ehrlichkeit im Audit ist die Grundlage des 90-Tage-Plans – geschönte Selbsteinschätzung bringt keinen Fortschritt.</a:t>
             </a:r>
           </a:p>
         </p:txBody>
@@ -867,7 +795,7 @@
           <a:lstStyle/>
           <a:p>
             <a:r>
-              <a:t>Siehe Trainerhandbuch (Sektion 3) für Moderationshinweise, Timing und erwartete Teilnehmerreaktionen.</a:t>
+              <a:t>Format 2 ist der stärkste Hebel: wer zuerst gibt, bekommt zurück. Digitale Sichtbarkeit ist Ergänzung, nicht Kern.</a:t>
             </a:r>
           </a:p>
         </p:txBody>
@@ -937,7 +865,12 @@
           <a:lstStyle/>
           <a:p>
             <a:r>
-              <a:t>Siehe Trainerhandbuch (Sektion 3) für Moderationshinweise, Timing und erwartete Teilnehmerreaktionen.</a:t>
+              <a:t>Fall Stefan Köhler: vom Geheimtipp zur Autorität durch systematische Sichtbarkeit über Fachbeiträge und Empfehlungen. Kein Talent, sondern Methode.</a:t>
+            </a:r>
+          </a:p>
+          <a:p>
+            <a:r>
+              <a:t>Moderation (HB Sec 3): Kein perfektes Tool nötig – ein leeres A3-Blatt und Stifte reichen Strukturhilfe anbieten: TN zeichnen sich in die Mitte; dann 3 Kreise: enger Kontakt / gelegentlicher Kontakt / Schlafende Verbindungen Häufig unbehagliches Schweigen – das ist produktiv, nicht dramatisch In der Arbeitsanweisung die Spalte „Nächster Schritt" in AB-1 explizit erwähnen: „Füllen Sie auch die letzte Spalte aus – was wäre Ihr nächster Schritt mit diesem Kontakt?" Puffer-Auftrag für Schnellfertige: „Schauen Sie sich Ihre Lückenanalyse auf AB-2 an. Welche drei Personen fehlen in Ihrem Netzwerk – und was wäre Ihr konkreter Anlass für einen ersten Kontakt? Schreiben Sie das unter ‚Nächster Schritt' in AB-1." Das überbrückt die Wartezeit und bereitet den Zweier-Austausch vor.</a:t>
             </a:r>
           </a:p>
         </p:txBody>
@@ -1007,7 +940,7 @@
           <a:lstStyle/>
           <a:p>
             <a:r>
-              <a:t>Siehe Trainerhandbuch (Sektion 3) für Moderationshinweise, Timing und erwartete Teilnehmerreaktionen.</a:t>
+              <a:t>Überleitung zum 90-Tage-Plan als Transferanker.</a:t>
             </a:r>
           </a:p>
         </p:txBody>
@@ -1077,77 +1010,7 @@
           <a:lstStyle/>
           <a:p>
             <a:r>
-              <a:t>Siehe Trainerhandbuch (Sektion 3) für Moderationshinweise, Timing und erwartete Teilnehmerreaktionen.</a:t>
-            </a:r>
-          </a:p>
-        </p:txBody>
-      </p:sp>
-      <p:sp>
-        <p:nvSpPr>
-          <p:cNvPr id="4" name="Slide Number Placeholder 3"/>
-          <p:cNvSpPr>
-            <a:spLocks noGrp="1"/>
-          </p:cNvSpPr>
-          <p:nvPr>
-            <p:ph type="sldNum" idx="5" sz="quarter"/>
-          </p:nvPr>
-        </p:nvSpPr>
-        <p:spPr/>
-      </p:sp>
-    </p:spTree>
-  </p:cSld>
-  <p:clrMapOvr>
-    <a:masterClrMapping/>
-  </p:clrMapOvr>
-</p:notes>
-</file>
-
-<file path=ppt/notesSlides/notesSlide9.xml><?xml version="1.0" encoding="utf-8"?>
-<p:notes xmlns:a="http://schemas.openxmlformats.org/drawingml/2006/main" xmlns:p="http://schemas.openxmlformats.org/presentationml/2006/main" xmlns:r="http://schemas.openxmlformats.org/officeDocument/2006/relationships">
-  <p:cSld>
-    <p:spTree>
-      <p:nvGrpSpPr>
-        <p:cNvPr id="1" name=""/>
-        <p:cNvGrpSpPr/>
-        <p:nvPr/>
-      </p:nvGrpSpPr>
-      <p:grpSpPr>
-        <a:xfrm>
-          <a:off x="0" y="0"/>
-          <a:ext cx="0" cy="0"/>
-          <a:chOff x="0" y="0"/>
-          <a:chExt cx="0" cy="0"/>
-        </a:xfrm>
-      </p:grpSpPr>
-      <p:sp>
-        <p:nvSpPr>
-          <p:cNvPr id="2" name="Slide Image Placeholder 1"/>
-          <p:cNvSpPr>
-            <a:spLocks noGrp="1"/>
-          </p:cNvSpPr>
-          <p:nvPr>
-            <p:ph type="sldImg" idx="2"/>
-          </p:nvPr>
-        </p:nvSpPr>
-        <p:spPr/>
-      </p:sp>
-      <p:sp>
-        <p:nvSpPr>
-          <p:cNvPr id="3" name="Notes Placeholder 2"/>
-          <p:cNvSpPr>
-            <a:spLocks noGrp="1"/>
-          </p:cNvSpPr>
-          <p:nvPr>
-            <p:ph type="body" idx="3" sz="quarter"/>
-          </p:nvPr>
-        </p:nvSpPr>
-        <p:spPr/>
-        <p:txBody>
-          <a:bodyPr/>
-          <a:lstStyle/>
-          <a:p>
-            <a:r>
-              <a:t>Siehe Trainerhandbuch (Sektion 3) für Moderationshinweise, Timing und erwartete Teilnehmerreaktionen.</a:t>
+              <a:t>90-Tage-Plan und Selbstcheck als Transferanker.</a:t>
             </a:r>
           </a:p>
         </p:txBody>
@@ -4965,7 +4828,7 @@
                 </a:solidFill>
                 <a:latin typeface="Arial"/>
               </a:rPr>
-              <a:t>Format 1: Fachbeiträge und Impulse</a:t>
+              <a:t>Vier Formate für Sichtbarkeit</a:t>
             </a:r>
           </a:p>
         </p:txBody>
@@ -4991,6 +4854,25 @@
             <a:spAutoFit/>
           </a:bodyPr>
           <a:lstStyle/>
+          <a:p>
+            <a:pPr marL="177800" indent="-177800">
+              <a:spcBef>
+                <a:spcPts val="600"/>
+              </a:spcBef>
+              <a:spcAft>
+                <a:spcPts val="200"/>
+              </a:spcAft>
+            </a:pPr>
+            <a:r>
+              <a:rPr sz="1200" i="1">
+                <a:solidFill>
+                  <a:srgbClr val="3D5466"/>
+                </a:solidFill>
+                <a:latin typeface="Arial"/>
+              </a:rPr>
+              <a:t>→  Sichtbarkeit entsteht durch Nutzen, nicht durch Werbung – man zeigt Expertise, indem man sie teilt.</a:t>
+            </a:r>
+          </a:p>
           <a:p>
             <a:pPr marL="190500" indent="-190500">
               <a:spcBef>
@@ -5007,7 +4889,7 @@
                 </a:solidFill>
                 <a:latin typeface="Arial"/>
               </a:rPr>
-              <a:t>▸  Was: Kurze, prägnante Wissensimpulse – nicht als Werbung, sondern als echten Mehrwert für Netzwerkkontakte.</a:t>
+              <a:t>▸  Fachbeiträge und Impulse: Wissen teilen statt Produkte bewerben.</a:t>
             </a:r>
           </a:p>
           <a:p>
@@ -5026,7 +4908,7 @@
                 </a:solidFill>
                 <a:latin typeface="Arial"/>
               </a:rPr>
-              <a:t>▸  Beispiele:</a:t>
+              <a:t>▸  Empfehlungen geben, bevor man welche bekommt – Reziprozität.</a:t>
             </a:r>
           </a:p>
           <a:p>
@@ -5045,45 +4927,7 @@
                 </a:solidFill>
                 <a:latin typeface="Arial"/>
               </a:rPr>
-              <a:t>▸  Monatliche E-Mail an 5–10 Steuerberater mit einem aktuellen Branchenhinweis: „Für Ihre Mandanten in der Landwirtschaft: GAP-Änderungen ab Q3 2026 – was das für Investitionsfinanzierungen bedeutet" (Hinweis: Regelmäßige E-Mail-Kommunikation an externe Multiplikatoren ist datenschutzrechtlich und complianceseitig vorab mit der Compliance-/Datenschutzabteilung der Bank abzustimmen. Empfehlung: Kommunikation über offizielle Bank-Einladungen oder bankveranstaltete Formate läuft oft reibungsloser.)</a:t>
-            </a:r>
-          </a:p>
-          <a:p>
-            <a:pPr marL="190500" indent="-190500">
-              <a:spcBef>
-                <a:spcPts val="400"/>
-              </a:spcBef>
-              <a:spcAft>
-                <a:spcPts val="200"/>
-              </a:spcAft>
-            </a:pPr>
-            <a:r>
-              <a:rPr sz="1300">
-                <a:solidFill>
-                  <a:srgbClr val="3D5466"/>
-                </a:solidFill>
-                <a:latin typeface="Arial"/>
-              </a:rPr>
-              <a:t>▸  Kurzer Vortrag (15 Min.) bei IHK-Frühstück zu einem konkreten Finanzierungsthema</a:t>
-            </a:r>
-          </a:p>
-          <a:p>
-            <a:pPr marL="190500" indent="-190500">
-              <a:spcBef>
-                <a:spcPts val="400"/>
-              </a:spcBef>
-              <a:spcAft>
-                <a:spcPts val="200"/>
-              </a:spcAft>
-            </a:pPr>
-            <a:r>
-              <a:rPr sz="1300">
-                <a:solidFill>
-                  <a:srgbClr val="3D5466"/>
-                </a:solidFill>
-                <a:latin typeface="Arial"/>
-              </a:rPr>
-              <a:t>▸  LinkedIn-Post mit einer praxisnahen Erkenntnis aus einem anonymisierten Kundengespräch</a:t>
+              <a:t>▸  Präsenz in Gremien und Verbänden; digitale Sichtbarkeit nachrangig und selektiv.</a:t>
             </a:r>
           </a:p>
         </p:txBody>
@@ -5199,7 +5043,7 @@
             <a:avLst/>
           </a:prstGeom>
           <a:solidFill>
-            <a:srgbClr val="EDEDF3"/>
+            <a:srgbClr val="1F2C56"/>
           </a:solidFill>
           <a:ln>
             <a:noFill/>
@@ -5229,57 +5073,14 @@
       </p:sp>
       <p:sp>
         <p:nvSpPr>
-          <p:cNvPr id="3" name="Rectangle 2"/>
-          <p:cNvSpPr/>
-          <p:nvPr/>
-        </p:nvSpPr>
-        <p:spPr>
-          <a:xfrm>
-            <a:off x="0" y="0"/>
-            <a:ext cx="12188952" cy="50292"/>
-          </a:xfrm>
-          <a:prstGeom prst="rect">
-            <a:avLst/>
-          </a:prstGeom>
-          <a:solidFill>
-            <a:srgbClr val="1F2C56"/>
-          </a:solidFill>
-          <a:ln>
-            <a:noFill/>
-          </a:ln>
-        </p:spPr>
-        <p:style>
-          <a:lnRef idx="1">
-            <a:schemeClr val="accent1"/>
-          </a:lnRef>
-          <a:fillRef idx="3">
-            <a:schemeClr val="accent1"/>
-          </a:fillRef>
-          <a:effectRef idx="2">
-            <a:schemeClr val="accent1"/>
-          </a:effectRef>
-          <a:fontRef idx="minor">
-            <a:schemeClr val="lt1"/>
-          </a:fontRef>
-        </p:style>
-        <p:txBody>
-          <a:bodyPr rtlCol="0" anchor="ctr"/>
-          <a:lstStyle/>
-          <a:p>
-            <a:pPr algn="ctr"/>
-          </a:p>
-        </p:txBody>
-      </p:sp>
-      <p:sp>
-        <p:nvSpPr>
-          <p:cNvPr id="4" name="TextBox 3"/>
+          <p:cNvPr id="3" name="TextBox 2"/>
           <p:cNvSpPr txBox="1"/>
           <p:nvPr/>
         </p:nvSpPr>
         <p:spPr>
           <a:xfrm>
-            <a:off x="685800" y="109728"/>
-            <a:ext cx="10817352" cy="228600"/>
+            <a:off x="685800" y="2377440"/>
+            <a:ext cx="10817352" cy="365760"/>
           </a:xfrm>
           <a:prstGeom prst="rect">
             <a:avLst/>
@@ -5294,70 +5095,27 @@
           <a:p>
             <a:pPr algn="l"/>
             <a:r>
-              <a:rPr sz="750">
-                <a:solidFill>
-                  <a:srgbClr val="78808C"/>
+              <a:rPr sz="1200">
+                <a:solidFill>
+                  <a:srgbClr val="D9C089"/>
                 </a:solidFill>
                 <a:latin typeface="Consolas"/>
               </a:rPr>
-              <a:t>M20  ·  INHALT</a:t>
-            </a:r>
-          </a:p>
-        </p:txBody>
-      </p:sp>
-      <p:sp>
-        <p:nvSpPr>
-          <p:cNvPr id="5" name="Rectangle 4"/>
+              <a:t>FALLARBEIT</a:t>
+            </a:r>
+          </a:p>
+        </p:txBody>
+      </p:sp>
+      <p:sp>
+        <p:nvSpPr>
+          <p:cNvPr id="4" name="Rectangle 3"/>
           <p:cNvSpPr/>
           <p:nvPr/>
         </p:nvSpPr>
         <p:spPr>
           <a:xfrm>
-            <a:off x="0" y="1234440"/>
-            <a:ext cx="12188952" cy="12700"/>
-          </a:xfrm>
-          <a:prstGeom prst="rect">
-            <a:avLst/>
-          </a:prstGeom>
-          <a:solidFill>
-            <a:srgbClr val="D8DFE4"/>
-          </a:solidFill>
-          <a:ln>
-            <a:noFill/>
-          </a:ln>
-        </p:spPr>
-        <p:style>
-          <a:lnRef idx="1">
-            <a:schemeClr val="accent1"/>
-          </a:lnRef>
-          <a:fillRef idx="3">
-            <a:schemeClr val="accent1"/>
-          </a:fillRef>
-          <a:effectRef idx="2">
-            <a:schemeClr val="accent1"/>
-          </a:effectRef>
-          <a:fontRef idx="minor">
-            <a:schemeClr val="lt1"/>
-          </a:fontRef>
-        </p:style>
-        <p:txBody>
-          <a:bodyPr rtlCol="0" anchor="ctr"/>
-          <a:lstStyle/>
-          <a:p>
-            <a:pPr algn="ctr"/>
-          </a:p>
-        </p:txBody>
-      </p:sp>
-      <p:sp>
-        <p:nvSpPr>
-          <p:cNvPr id="6" name="Rectangle 5"/>
-          <p:cNvSpPr/>
-          <p:nvPr/>
-        </p:nvSpPr>
-        <p:spPr>
-          <a:xfrm>
-            <a:off x="685800" y="502920"/>
-            <a:ext cx="36576" cy="658368"/>
+            <a:off x="685800" y="2788920"/>
+            <a:ext cx="548640" cy="38100"/>
           </a:xfrm>
           <a:prstGeom prst="rect">
             <a:avLst/>
@@ -5393,14 +5151,14 @@
       </p:sp>
       <p:sp>
         <p:nvSpPr>
-          <p:cNvPr id="7" name="TextBox 6"/>
+          <p:cNvPr id="5" name="TextBox 4"/>
           <p:cNvSpPr txBox="1"/>
           <p:nvPr/>
         </p:nvSpPr>
         <p:spPr>
           <a:xfrm>
-            <a:off x="813816" y="502920"/>
-            <a:ext cx="10634472" cy="685800"/>
+            <a:off x="685800" y="3017520"/>
+            <a:ext cx="10817352" cy="1463040"/>
           </a:xfrm>
           <a:prstGeom prst="rect">
             <a:avLst/>
@@ -5415,27 +5173,27 @@
           <a:p>
             <a:pPr algn="l"/>
             <a:r>
-              <a:rPr sz="2400" b="1" i="0">
-                <a:solidFill>
-                  <a:srgbClr val="1F2C56"/>
+              <a:rPr sz="4000" b="1" i="0">
+                <a:solidFill>
+                  <a:srgbClr val="FFFFFF"/>
                 </a:solidFill>
                 <a:latin typeface="Arial"/>
               </a:rPr>
-              <a:t>Format 2: Empfehlungen geben, bevor man welche bekommt</a:t>
-            </a:r>
-          </a:p>
-        </p:txBody>
-      </p:sp>
-      <p:sp>
-        <p:nvSpPr>
-          <p:cNvPr id="8" name="TextBox 7"/>
+              <a:t>Praxiscase &amp; 90-Tage-Plan</a:t>
+            </a:r>
+          </a:p>
+        </p:txBody>
+      </p:sp>
+      <p:sp>
+        <p:nvSpPr>
+          <p:cNvPr id="6" name="TextBox 5"/>
           <p:cNvSpPr txBox="1"/>
           <p:nvPr/>
         </p:nvSpPr>
         <p:spPr>
           <a:xfrm>
-            <a:off x="685800" y="1417320"/>
-            <a:ext cx="10817352" cy="4892040"/>
+            <a:off x="685800" y="4480560"/>
+            <a:ext cx="8653881" cy="1280160"/>
           </a:xfrm>
           <a:prstGeom prst="rect">
             <a:avLst/>
@@ -5443,84 +5201,34 @@
           <a:noFill/>
         </p:spPr>
         <p:txBody>
-          <a:bodyPr wrap="square" anchor="ctr">
+          <a:bodyPr wrap="square">
             <a:spAutoFit/>
           </a:bodyPr>
           <a:lstStyle/>
           <a:p>
-            <a:pPr marL="190500" indent="-190500">
-              <a:spcBef>
-                <a:spcPts val="400"/>
-              </a:spcBef>
-              <a:spcAft>
-                <a:spcPts val="200"/>
-              </a:spcAft>
-            </a:pPr>
-            <a:r>
-              <a:rPr sz="1300">
-                <a:solidFill>
-                  <a:srgbClr val="3D5466"/>
+            <a:pPr algn="l"/>
+            <a:r>
+              <a:rPr sz="1600" b="0" i="0">
+                <a:solidFill>
+                  <a:srgbClr val="C8D2E6"/>
                 </a:solidFill>
                 <a:latin typeface="Arial"/>
               </a:rPr>
-              <a:t>▸  Praxisregel: „Ein guter Netzwerkpartner merkt, dass er zu mir gehört, bevor er das erste Mal mit mir gearbeitet hat."</a:t>
-            </a:r>
-          </a:p>
-        </p:txBody>
-      </p:sp>
-      <p:sp>
-        <p:nvSpPr>
-          <p:cNvPr id="9" name="Rectangle 8"/>
-          <p:cNvSpPr/>
-          <p:nvPr/>
-        </p:nvSpPr>
-        <p:spPr>
-          <a:xfrm>
-            <a:off x="0" y="6510528"/>
-            <a:ext cx="12188952" cy="347472"/>
-          </a:xfrm>
-          <a:prstGeom prst="rect">
-            <a:avLst/>
-          </a:prstGeom>
-          <a:solidFill>
-            <a:srgbClr val="0A1937"/>
-          </a:solidFill>
-          <a:ln>
-            <a:noFill/>
-          </a:ln>
-        </p:spPr>
-        <p:style>
-          <a:lnRef idx="1">
-            <a:schemeClr val="accent1"/>
-          </a:lnRef>
-          <a:fillRef idx="3">
-            <a:schemeClr val="accent1"/>
-          </a:fillRef>
-          <a:effectRef idx="2">
-            <a:schemeClr val="accent1"/>
-          </a:effectRef>
-          <a:fontRef idx="minor">
-            <a:schemeClr val="lt1"/>
-          </a:fontRef>
-        </p:style>
-        <p:txBody>
-          <a:bodyPr rtlCol="0" anchor="ctr"/>
-          <a:lstStyle/>
-          <a:p>
-            <a:pPr algn="ctr"/>
-          </a:p>
-        </p:txBody>
-      </p:sp>
-      <p:sp>
-        <p:nvSpPr>
-          <p:cNvPr id="10" name="TextBox 9"/>
+              <a:t>Vom Geheimtipp zur Autorität – einen konkreten Netzwerkplan bauen.</a:t>
+            </a:r>
+          </a:p>
+        </p:txBody>
+      </p:sp>
+      <p:sp>
+        <p:nvSpPr>
+          <p:cNvPr id="7" name="TextBox 6"/>
           <p:cNvSpPr txBox="1"/>
           <p:nvPr/>
         </p:nvSpPr>
         <p:spPr>
           <a:xfrm>
-            <a:off x="685800" y="6583680"/>
-            <a:ext cx="6490411" cy="256032"/>
+            <a:off x="685800" y="6355080"/>
+            <a:ext cx="10817352" cy="274320"/>
           </a:xfrm>
           <a:prstGeom prst="rect">
             <a:avLst/>
@@ -5537,7 +5245,7 @@
             <a:r>
               <a:rPr sz="700">
                 <a:solidFill>
-                  <a:srgbClr val="A0B4D2"/>
+                  <a:srgbClr val="8CA0C3"/>
                 </a:solidFill>
                 <a:latin typeface="Consolas"/>
               </a:rPr>
@@ -5680,7 +5388,7 @@
                 </a:solidFill>
                 <a:latin typeface="Consolas"/>
               </a:rPr>
-              <a:t>M20  ·  INHALT</a:t>
+              <a:t>M20  ·  ARBEITSBLATT</a:t>
             </a:r>
           </a:p>
         </p:txBody>
@@ -5801,7 +5509,7 @@
                 </a:solidFill>
                 <a:latin typeface="Arial"/>
               </a:rPr>
-              <a:t>Format 3: Präsenz in Gremien und Verbänden</a:t>
+              <a:t>Netzwerkkarte und 90-Tage-Plan erstellen</a:t>
             </a:r>
           </a:p>
         </p:txBody>
@@ -5814,8 +5522,8 @@
         </p:nvSpPr>
         <p:spPr>
           <a:xfrm>
-            <a:off x="685800" y="1417320"/>
-            <a:ext cx="10817352" cy="4892040"/>
+            <a:off x="685800" y="1554480"/>
+            <a:ext cx="10817352" cy="3840480"/>
           </a:xfrm>
           <a:prstGeom prst="rect">
             <a:avLst/>
@@ -5823,7 +5531,7 @@
           <a:noFill/>
         </p:spPr>
         <p:txBody>
-          <a:bodyPr wrap="square" anchor="ctr">
+          <a:bodyPr wrap="square">
             <a:spAutoFit/>
           </a:bodyPr>
           <a:lstStyle/>
@@ -5837,13 +5545,13 @@
               </a:spcAft>
             </a:pPr>
             <a:r>
-              <a:rPr sz="1300">
+              <a:rPr sz="1400">
                 <a:solidFill>
                   <a:srgbClr val="3D5466"/>
                 </a:solidFill>
                 <a:latin typeface="Arial"/>
               </a:rPr>
-              <a:t>▸  Strategisch wählen: Nicht jede Mitgliedschaft lohnt sich. Kriterien:</a:t>
+              <a:t>▸  Erstellen Sie Ihre persönliche Netzwerkkarte über die drei Dimensionen (AB-1).</a:t>
             </a:r>
           </a:p>
           <a:p>
@@ -5856,13 +5564,13 @@
               </a:spcAft>
             </a:pPr>
             <a:r>
-              <a:rPr sz="1300">
+              <a:rPr sz="1400">
                 <a:solidFill>
                   <a:srgbClr val="3D5466"/>
                 </a:solidFill>
                 <a:latin typeface="Arial"/>
               </a:rPr>
-              <a:t>▸  Sind meine Zielkunden oder ihre Berater dort aktiv?</a:t>
+              <a:t>▸  Führen Sie das Netzwerk-Audit durch und identifizieren Sie die fehlenden Brücken.</a:t>
             </a:r>
           </a:p>
           <a:p>
@@ -5875,58 +5583,98 @@
               </a:spcAft>
             </a:pPr>
             <a:r>
-              <a:rPr sz="1300">
+              <a:rPr sz="1400">
                 <a:solidFill>
                   <a:srgbClr val="3D5466"/>
                 </a:solidFill>
                 <a:latin typeface="Arial"/>
               </a:rPr>
-              <a:t>▸  Gibt es eine Möglichkeit, sich inhaltlich einzubringen (Vortrag, Arbeitskreis)?</a:t>
-            </a:r>
-          </a:p>
-          <a:p>
-            <a:pPr marL="190500" indent="-190500">
-              <a:spcBef>
-                <a:spcPts val="400"/>
-              </a:spcBef>
-              <a:spcAft>
-                <a:spcPts val="200"/>
-              </a:spcAft>
-            </a:pPr>
-            <a:r>
-              <a:rPr sz="1300">
-                <a:solidFill>
-                  <a:srgbClr val="3D5466"/>
+              <a:t>▸  Entwickeln Sie Ihren 90-Tage-Aktionsplan mit konkreten Schritten (AB-3).</a:t>
+            </a:r>
+          </a:p>
+        </p:txBody>
+      </p:sp>
+      <p:sp>
+        <p:nvSpPr>
+          <p:cNvPr id="9" name="Rectangle 8"/>
+          <p:cNvSpPr/>
+          <p:nvPr/>
+        </p:nvSpPr>
+        <p:spPr>
+          <a:xfrm>
+            <a:off x="685800" y="5486400"/>
+            <a:ext cx="10817352" cy="640080"/>
+          </a:xfrm>
+          <a:prstGeom prst="rect">
+            <a:avLst/>
+          </a:prstGeom>
+          <a:solidFill>
+            <a:srgbClr val="1F2C56"/>
+          </a:solidFill>
+          <a:ln>
+            <a:noFill/>
+          </a:ln>
+        </p:spPr>
+        <p:style>
+          <a:lnRef idx="1">
+            <a:schemeClr val="accent1"/>
+          </a:lnRef>
+          <a:fillRef idx="3">
+            <a:schemeClr val="accent1"/>
+          </a:fillRef>
+          <a:effectRef idx="2">
+            <a:schemeClr val="accent1"/>
+          </a:effectRef>
+          <a:fontRef idx="minor">
+            <a:schemeClr val="lt1"/>
+          </a:fontRef>
+        </p:style>
+        <p:txBody>
+          <a:bodyPr rtlCol="0" anchor="ctr"/>
+          <a:lstStyle/>
+          <a:p>
+            <a:pPr algn="ctr"/>
+          </a:p>
+        </p:txBody>
+      </p:sp>
+      <p:sp>
+        <p:nvSpPr>
+          <p:cNvPr id="10" name="TextBox 9"/>
+          <p:cNvSpPr txBox="1"/>
+          <p:nvPr/>
+        </p:nvSpPr>
+        <p:spPr>
+          <a:xfrm>
+            <a:off x="868680" y="5596128"/>
+            <a:ext cx="10451592" cy="457200"/>
+          </a:xfrm>
+          <a:prstGeom prst="rect">
+            <a:avLst/>
+          </a:prstGeom>
+          <a:noFill/>
+        </p:spPr>
+        <p:txBody>
+          <a:bodyPr wrap="square">
+            <a:spAutoFit/>
+          </a:bodyPr>
+          <a:lstStyle/>
+          <a:p>
+            <a:pPr algn="l"/>
+            <a:r>
+              <a:rPr sz="1300" b="1" i="0">
+                <a:solidFill>
+                  <a:srgbClr val="FFFFFF"/>
                 </a:solidFill>
                 <a:latin typeface="Arial"/>
               </a:rPr>
-              <a:t>▸  Lässt sich die Zeitinvestition rechtfertigen (qualitativ hochwertige Kontakte)?</a:t>
-            </a:r>
-          </a:p>
-          <a:p>
-            <a:pPr marL="190500" indent="-190500">
-              <a:spcBef>
-                <a:spcPts val="400"/>
-              </a:spcBef>
-              <a:spcAft>
-                <a:spcPts val="200"/>
-              </a:spcAft>
-            </a:pPr>
-            <a:r>
-              <a:rPr sz="1300">
-                <a:solidFill>
-                  <a:srgbClr val="3D5466"/>
-                </a:solidFill>
-                <a:latin typeface="Arial"/>
-              </a:rPr>
-              <a:t>▸  Empfehlungen für FK-Berater in Süddeutschland – bewährteste Formate nach Zeitaufwand und Netzwerkqualität:</a:t>
-            </a:r>
-          </a:p>
-        </p:txBody>
-      </p:sp>
-      <p:sp>
-        <p:nvSpPr>
-          <p:cNvPr id="9" name="Rectangle 8"/>
+              <a:t>→  Bearbeitung im Teilnehmer-Workbook (Arbeitsblatt mit Ausfüllfeldern)</a:t>
+            </a:r>
+          </a:p>
+        </p:txBody>
+      </p:sp>
+      <p:sp>
+        <p:nvSpPr>
+          <p:cNvPr id="11" name="Rectangle 10"/>
           <p:cNvSpPr/>
           <p:nvPr/>
         </p:nvSpPr>
@@ -5969,7 +5717,7 @@
       </p:sp>
       <p:sp>
         <p:nvSpPr>
-          <p:cNvPr id="10" name="TextBox 9"/>
+          <p:cNvPr id="12" name="TextBox 11"/>
           <p:cNvSpPr txBox="1"/>
           <p:nvPr/>
         </p:nvSpPr>
@@ -6257,7 +6005,7 @@
                 </a:solidFill>
                 <a:latin typeface="Arial"/>
               </a:rPr>
-              <a:t>Format 4: Digitale Sichtbarkeit (nachrangig, selektiv)</a:t>
+              <a:t>Prinzip dieses Moduls</a:t>
             </a:r>
           </a:p>
         </p:txBody>
@@ -6279,10 +6027,29 @@
           <a:noFill/>
         </p:spPr>
         <p:txBody>
-          <a:bodyPr wrap="square">
+          <a:bodyPr wrap="square" anchor="ctr">
             <a:spAutoFit/>
           </a:bodyPr>
           <a:lstStyle/>
+          <a:p>
+            <a:pPr marL="177800" indent="-177800">
+              <a:spcBef>
+                <a:spcPts val="600"/>
+              </a:spcBef>
+              <a:spcAft>
+                <a:spcPts val="200"/>
+              </a:spcAft>
+            </a:pPr>
+            <a:r>
+              <a:rPr sz="1200" i="1">
+                <a:solidFill>
+                  <a:srgbClr val="3D5466"/>
+                </a:solidFill>
+                <a:latin typeface="Arial"/>
+              </a:rPr>
+              <a:t>→  Beziehungen baut man, bevor man sie braucht.</a:t>
+            </a:r>
+          </a:p>
           <a:p>
             <a:pPr marL="190500" indent="-190500">
               <a:spcBef>
@@ -6299,216 +6066,7 @@
                 </a:solidFill>
                 <a:latin typeface="Arial"/>
               </a:rPr>
-              <a:t>▸  ## 4.5 Der 90-Tage-Netzwerkplan</a:t>
-            </a:r>
-          </a:p>
-          <a:p>
-            <a:pPr marL="190500" indent="-190500">
-              <a:spcBef>
-                <a:spcPts val="400"/>
-              </a:spcBef>
-              <a:spcAft>
-                <a:spcPts val="200"/>
-              </a:spcAft>
-            </a:pPr>
-            <a:r>
-              <a:rPr sz="1300">
-                <a:solidFill>
-                  <a:srgbClr val="3D5466"/>
-                </a:solidFill>
-                <a:latin typeface="Arial"/>
-              </a:rPr>
-              <a:t>▸  Ein Netzwerk entsteht nicht durch einmalige Aktionen. Es braucht ein System – klein, aber regelmäßig.</a:t>
-            </a:r>
-          </a:p>
-          <a:p>
-            <a:pPr marL="190500" indent="-190500">
-              <a:spcBef>
-                <a:spcPts val="400"/>
-              </a:spcBef>
-              <a:spcAft>
-                <a:spcPts val="200"/>
-              </a:spcAft>
-            </a:pPr>
-            <a:r>
-              <a:rPr sz="1300">
-                <a:solidFill>
-                  <a:srgbClr val="3D5466"/>
-                </a:solidFill>
-                <a:latin typeface="Arial"/>
-              </a:rPr>
-              <a:t>▸  ## 4.6 Praxiscase: Stefan Köhler – vom Geheimtipp zur Autorität</a:t>
-            </a:r>
-          </a:p>
-          <a:p>
-            <a:pPr marL="190500" indent="-190500">
-              <a:spcBef>
-                <a:spcPts val="400"/>
-              </a:spcBef>
-              <a:spcAft>
-                <a:spcPts val="200"/>
-              </a:spcAft>
-            </a:pPr>
-            <a:r>
-              <a:rPr sz="1300">
-                <a:solidFill>
-                  <a:srgbClr val="3D5466"/>
-                </a:solidFill>
-                <a:latin typeface="Arial"/>
-              </a:rPr>
-              <a:t>▸  Ausgangssituation</a:t>
-            </a:r>
-          </a:p>
-          <a:p>
-            <a:pPr marL="190500" indent="-190500">
-              <a:spcBef>
-                <a:spcPts val="400"/>
-              </a:spcBef>
-              <a:spcAft>
-                <a:spcPts val="200"/>
-              </a:spcAft>
-            </a:pPr>
-            <a:r>
-              <a:rPr sz="1300">
-                <a:solidFill>
-                  <a:srgbClr val="3D5466"/>
-                </a:solidFill>
-                <a:latin typeface="Arial"/>
-              </a:rPr>
-              <a:t>▸  Stefan arbeitet hart, berät gut – aber er ist unsichtbar.</a:t>
-            </a:r>
-          </a:p>
-          <a:p>
-            <a:pPr marL="190500" indent="-190500">
-              <a:spcBef>
-                <a:spcPts val="400"/>
-              </a:spcBef>
-              <a:spcAft>
-                <a:spcPts val="200"/>
-              </a:spcAft>
-            </a:pPr>
-            <a:r>
-              <a:rPr sz="1300">
-                <a:solidFill>
-                  <a:srgbClr val="3D5466"/>
-                </a:solidFill>
-                <a:latin typeface="Arial"/>
-              </a:rPr>
-              <a:t>▸  Was Stefan verändert (in 90 Tagen)</a:t>
-            </a:r>
-          </a:p>
-          <a:p>
-            <a:pPr marL="190500" indent="-190500">
-              <a:spcBef>
-                <a:spcPts val="400"/>
-              </a:spcBef>
-              <a:spcAft>
-                <a:spcPts val="200"/>
-              </a:spcAft>
-            </a:pPr>
-            <a:r>
-              <a:rPr sz="1300">
-                <a:solidFill>
-                  <a:srgbClr val="3D5466"/>
-                </a:solidFill>
-                <a:latin typeface="Arial"/>
-              </a:rPr>
-              <a:t>▸  Monat 1 – Analyse &amp; Positionierung:</a:t>
-            </a:r>
-          </a:p>
-          <a:p>
-            <a:pPr marL="190500" indent="-190500">
-              <a:spcBef>
-                <a:spcPts val="400"/>
-              </a:spcBef>
-              <a:spcAft>
-                <a:spcPts val="200"/>
-              </a:spcAft>
-            </a:pPr>
-            <a:r>
-              <a:rPr sz="1300">
-                <a:solidFill>
-                  <a:srgbClr val="3D5466"/>
-                </a:solidFill>
-                <a:latin typeface="Arial"/>
-              </a:rPr>
-              <a:t>▸  Stefan erstellt seine persönliche Netzwerkkarte. Ergebnis: Intern gut vernetzt, intern überbekannt. Extern: kaum Kontakte außerhalb seiner eigenen Kunden.</a:t>
-            </a:r>
-          </a:p>
-          <a:p>
-            <a:pPr marL="190500" indent="-190500">
-              <a:spcBef>
-                <a:spcPts val="400"/>
-              </a:spcBef>
-              <a:spcAft>
-                <a:spcPts val="200"/>
-              </a:spcAft>
-            </a:pPr>
-            <a:r>
-              <a:rPr sz="1300">
-                <a:solidFill>
-                  <a:srgbClr val="3D5466"/>
-                </a:solidFill>
-                <a:latin typeface="Arial"/>
-              </a:rPr>
-              <a:t>▸  Er identifiziert drei Multiplikatoren, die für sein Zielfeld entscheidend sind: (1) der größte Steuerberater für Landwirte in der Region, (2) der Geschäftsführer des regionalen Maschinenrings, (3) der BBV-Kreisverband.</a:t>
-            </a:r>
-          </a:p>
-          <a:p>
-            <a:pPr marL="190500" indent="-190500">
-              <a:spcBef>
-                <a:spcPts val="400"/>
-              </a:spcBef>
-              <a:spcAft>
-                <a:spcPts val="200"/>
-              </a:spcAft>
-            </a:pPr>
-            <a:r>
-              <a:rPr sz="1300">
-                <a:solidFill>
-                  <a:srgbClr val="3D5466"/>
-                </a:solidFill>
-                <a:latin typeface="Arial"/>
-              </a:rPr>
-              <a:t>▸  Er formuliert sein Positionierungsversprechen: „Ich bin der Ansprechpartner für Agrar- und Forstbetriebe ab 200 ha im Allgäu, wenn es um Investitionsfinanzierung, Betriebsumstrukturierung und Nachfolge geht."</a:t>
-            </a:r>
-          </a:p>
-          <a:p>
-            <a:pPr marL="190500" indent="-190500">
-              <a:spcBef>
-                <a:spcPts val="400"/>
-              </a:spcBef>
-              <a:spcAft>
-                <a:spcPts val="200"/>
-              </a:spcAft>
-            </a:pPr>
-            <a:r>
-              <a:rPr sz="1300">
-                <a:solidFill>
-                  <a:srgbClr val="3D5466"/>
-                </a:solidFill>
-                <a:latin typeface="Arial"/>
-              </a:rPr>
-              <a:t>▸  Monat 2 – Erste Kontakte:</a:t>
-            </a:r>
-          </a:p>
-          <a:p>
-            <a:pPr marL="190500" indent="-190500">
-              <a:spcBef>
-                <a:spcPts val="400"/>
-              </a:spcBef>
-              <a:spcAft>
-                <a:spcPts val="200"/>
-              </a:spcAft>
-            </a:pPr>
-            <a:r>
-              <a:rPr sz="1300">
-                <a:solidFill>
-                  <a:srgbClr val="3D5466"/>
-                </a:solidFill>
-                <a:latin typeface="Arial"/>
-              </a:rPr>
-              <a:t>▸  Stefan ruft den Steuerberater an – nicht mit einem Verkaufsangebot, sondern mit einer konkreten Einladung: „Ich würde Ihnen gerne zeigen, wie wir bei Biogasinvestitionen vorgehen – vielleicht ist das für Ihre Mandanten relevant." Er bezieht sich dabei auf eine jüngste GAP-Meldung im Bayerischen Landwirtschaftlichen Wochenblatt als sachlichen Aufhänger. Der Steuerberater ist anfangs reserviert – Bankberater haben keinen guten Ruf bei Steuerberatern, die Direktvertrieb fürchten. Stefan macht deshalb keinen Produktbezug, sondern bietet ein fachliches Kurzgespräch über Fördermittel an, das dem Steuerberater selbst gegenüber seinen Mandanten nützt. → Treffen findet statt. Wäre möglich: Vorab-Kontakt über das BBV-Netzwerk oder ein gemeinsames IHK-Event hätte diesen Anruf noch einfacher gemacht.</a:t>
+              <a:t>▸  Ein Netzwerk aus Brücken (nicht nur Kontakten) und gezielte Sichtbarkeit bringen Anfragen, bevor der Wettbewerb sie sieht.</a:t>
             </a:r>
           </a:p>
         </p:txBody>
@@ -6846,7 +6404,7 @@
                 </a:solidFill>
                 <a:latin typeface="Arial"/>
               </a:rPr>
-              <a:t>AB-1: Persönliche Netzwerkkarte</a:t>
+              <a:t>Reflexion und Selbstcheck</a:t>
             </a:r>
           </a:p>
         </p:txBody>
@@ -6888,7 +6446,45 @@
                 </a:solidFill>
                 <a:latin typeface="Arial"/>
               </a:rPr>
-              <a:t>▸  (Zeichnen oder tabellarisch ausfüllen)</a:t>
+              <a:t>▸  Welche der drei Netzwerkdimensionen ist bei Ihnen am schwächsten?</a:t>
+            </a:r>
+          </a:p>
+          <a:p>
+            <a:pPr marL="190500" indent="-190500">
+              <a:spcBef>
+                <a:spcPts val="400"/>
+              </a:spcBef>
+              <a:spcAft>
+                <a:spcPts val="200"/>
+              </a:spcAft>
+            </a:pPr>
+            <a:r>
+              <a:rPr sz="1300">
+                <a:solidFill>
+                  <a:srgbClr val="3D5466"/>
+                </a:solidFill>
+                <a:latin typeface="Arial"/>
+              </a:rPr>
+              <a:t>▸  Wem könnten Sie diese Woche eine Empfehlung geben, ohne eine Gegenleistung zu erwarten?</a:t>
+            </a:r>
+          </a:p>
+          <a:p>
+            <a:pPr marL="190500" indent="-190500">
+              <a:spcBef>
+                <a:spcPts val="400"/>
+              </a:spcBef>
+              <a:spcAft>
+                <a:spcPts val="200"/>
+              </a:spcAft>
+            </a:pPr>
+            <a:r>
+              <a:rPr sz="1300">
+                <a:solidFill>
+                  <a:srgbClr val="3D5466"/>
+                </a:solidFill>
+                <a:latin typeface="Arial"/>
+              </a:rPr>
+              <a:t>▸  Welche eine Brücke bauen Sie in den nächsten 90 Tagen zuerst?</a:t>
             </a:r>
           </a:p>
         </p:txBody>
@@ -6967,1572 +6563,6 @@
                 <a:latin typeface="Consolas"/>
               </a:rPr>
               <a:t>FKB Campus  ·  M20</a:t>
-            </a:r>
-          </a:p>
-        </p:txBody>
-      </p:sp>
-    </p:spTree>
-  </p:cSld>
-  <p:clrMapOvr>
-    <a:masterClrMapping/>
-  </p:clrMapOvr>
-</p:sld>
-</file>
-
-<file path=ppt/slides/slide15.xml><?xml version="1.0" encoding="utf-8"?>
-<p:sld xmlns:a="http://schemas.openxmlformats.org/drawingml/2006/main" xmlns:p="http://schemas.openxmlformats.org/presentationml/2006/main" xmlns:r="http://schemas.openxmlformats.org/officeDocument/2006/relationships">
-  <p:cSld>
-    <p:spTree>
-      <p:nvGrpSpPr>
-        <p:cNvPr id="1" name=""/>
-        <p:cNvGrpSpPr/>
-        <p:nvPr/>
-      </p:nvGrpSpPr>
-      <p:grpSpPr/>
-      <p:sp>
-        <p:nvSpPr>
-          <p:cNvPr id="2" name="Rectangle 1"/>
-          <p:cNvSpPr/>
-          <p:nvPr/>
-        </p:nvSpPr>
-        <p:spPr>
-          <a:xfrm>
-            <a:off x="0" y="0"/>
-            <a:ext cx="12188952" cy="6858000"/>
-          </a:xfrm>
-          <a:prstGeom prst="rect">
-            <a:avLst/>
-          </a:prstGeom>
-          <a:solidFill>
-            <a:srgbClr val="FFFFFF"/>
-          </a:solidFill>
-          <a:ln>
-            <a:noFill/>
-          </a:ln>
-        </p:spPr>
-        <p:style>
-          <a:lnRef idx="1">
-            <a:schemeClr val="accent1"/>
-          </a:lnRef>
-          <a:fillRef idx="3">
-            <a:schemeClr val="accent1"/>
-          </a:fillRef>
-          <a:effectRef idx="2">
-            <a:schemeClr val="accent1"/>
-          </a:effectRef>
-          <a:fontRef idx="minor">
-            <a:schemeClr val="lt1"/>
-          </a:fontRef>
-        </p:style>
-        <p:txBody>
-          <a:bodyPr rtlCol="0" anchor="ctr"/>
-          <a:lstStyle/>
-          <a:p>
-            <a:pPr algn="ctr"/>
-          </a:p>
-        </p:txBody>
-      </p:sp>
-      <p:sp>
-        <p:nvSpPr>
-          <p:cNvPr id="3" name="Rectangle 2"/>
-          <p:cNvSpPr/>
-          <p:nvPr/>
-        </p:nvSpPr>
-        <p:spPr>
-          <a:xfrm>
-            <a:off x="0" y="0"/>
-            <a:ext cx="12188952" cy="50292"/>
-          </a:xfrm>
-          <a:prstGeom prst="rect">
-            <a:avLst/>
-          </a:prstGeom>
-          <a:solidFill>
-            <a:srgbClr val="1F2C56"/>
-          </a:solidFill>
-          <a:ln>
-            <a:noFill/>
-          </a:ln>
-        </p:spPr>
-        <p:style>
-          <a:lnRef idx="1">
-            <a:schemeClr val="accent1"/>
-          </a:lnRef>
-          <a:fillRef idx="3">
-            <a:schemeClr val="accent1"/>
-          </a:fillRef>
-          <a:effectRef idx="2">
-            <a:schemeClr val="accent1"/>
-          </a:effectRef>
-          <a:fontRef idx="minor">
-            <a:schemeClr val="lt1"/>
-          </a:fontRef>
-        </p:style>
-        <p:txBody>
-          <a:bodyPr rtlCol="0" anchor="ctr"/>
-          <a:lstStyle/>
-          <a:p>
-            <a:pPr algn="ctr"/>
-          </a:p>
-        </p:txBody>
-      </p:sp>
-      <p:sp>
-        <p:nvSpPr>
-          <p:cNvPr id="4" name="TextBox 3"/>
-          <p:cNvSpPr txBox="1"/>
-          <p:nvPr/>
-        </p:nvSpPr>
-        <p:spPr>
-          <a:xfrm>
-            <a:off x="685800" y="109728"/>
-            <a:ext cx="10817352" cy="228600"/>
-          </a:xfrm>
-          <a:prstGeom prst="rect">
-            <a:avLst/>
-          </a:prstGeom>
-          <a:noFill/>
-        </p:spPr>
-        <p:txBody>
-          <a:bodyPr wrap="none">
-            <a:spAutoFit/>
-          </a:bodyPr>
-          <a:lstStyle/>
-          <a:p>
-            <a:pPr algn="l"/>
-            <a:r>
-              <a:rPr sz="750">
-                <a:solidFill>
-                  <a:srgbClr val="78808C"/>
-                </a:solidFill>
-                <a:latin typeface="Consolas"/>
-              </a:rPr>
-              <a:t>M20  ·  ÜBERSICHT</a:t>
-            </a:r>
-          </a:p>
-        </p:txBody>
-      </p:sp>
-      <p:sp>
-        <p:nvSpPr>
-          <p:cNvPr id="5" name="TextBox 4"/>
-          <p:cNvSpPr txBox="1"/>
-          <p:nvPr/>
-        </p:nvSpPr>
-        <p:spPr>
-          <a:xfrm>
-            <a:off x="685800" y="502920"/>
-            <a:ext cx="10817352" cy="594360"/>
-          </a:xfrm>
-          <a:prstGeom prst="rect">
-            <a:avLst/>
-          </a:prstGeom>
-          <a:noFill/>
-        </p:spPr>
-        <p:txBody>
-          <a:bodyPr wrap="square">
-            <a:spAutoFit/>
-          </a:bodyPr>
-          <a:lstStyle/>
-          <a:p>
-            <a:pPr algn="l"/>
-            <a:r>
-              <a:rPr sz="2000" b="1" i="0">
-                <a:solidFill>
-                  <a:srgbClr val="1F2C56"/>
-                </a:solidFill>
-                <a:latin typeface="Arial"/>
-              </a:rPr>
-              <a:t>AB-1: Persönliche Netzwerkkarte</a:t>
-            </a:r>
-          </a:p>
-        </p:txBody>
-      </p:sp>
-      <p:sp>
-        <p:nvSpPr>
-          <p:cNvPr id="6" name="Rectangle 5"/>
-          <p:cNvSpPr/>
-          <p:nvPr/>
-        </p:nvSpPr>
-        <p:spPr>
-          <a:xfrm>
-            <a:off x="685800" y="1143000"/>
-            <a:ext cx="10817352" cy="25400"/>
-          </a:xfrm>
-          <a:prstGeom prst="rect">
-            <a:avLst/>
-          </a:prstGeom>
-          <a:solidFill>
-            <a:srgbClr val="D9C089"/>
-          </a:solidFill>
-          <a:ln>
-            <a:noFill/>
-          </a:ln>
-        </p:spPr>
-        <p:style>
-          <a:lnRef idx="1">
-            <a:schemeClr val="accent1"/>
-          </a:lnRef>
-          <a:fillRef idx="3">
-            <a:schemeClr val="accent1"/>
-          </a:fillRef>
-          <a:effectRef idx="2">
-            <a:schemeClr val="accent1"/>
-          </a:effectRef>
-          <a:fontRef idx="minor">
-            <a:schemeClr val="lt1"/>
-          </a:fontRef>
-        </p:style>
-        <p:txBody>
-          <a:bodyPr rtlCol="0" anchor="ctr"/>
-          <a:lstStyle/>
-          <a:p>
-            <a:pPr algn="ctr"/>
-          </a:p>
-        </p:txBody>
-      </p:sp>
-      <p:graphicFrame>
-        <p:nvGraphicFramePr>
-          <p:cNvPr id="7" name="Table 6"/>
-          <p:cNvGraphicFramePr>
-            <a:graphicFrameLocks noGrp="1"/>
-          </p:cNvGraphicFramePr>
-          <p:nvPr/>
-        </p:nvGraphicFramePr>
-        <p:xfrm>
-          <a:off x="685800" y="1417320"/>
-          <a:ext cx="10817352" cy="3456432"/>
-        </p:xfrm>
-        <a:graphic>
-          <a:graphicData uri="http://schemas.openxmlformats.org/drawingml/2006/table">
-            <a:tbl>
-              <a:tblPr firstRow="1" bandRow="1">
-                <a:tableStyleId>{5C22544A-7EE6-4342-B048-85BDC9FD1C3A}</a:tableStyleId>
-              </a:tblPr>
-              <a:tblGrid>
-                <a:gridCol w="2163470"/>
-                <a:gridCol w="2163470"/>
-                <a:gridCol w="2163470"/>
-                <a:gridCol w="2163470"/>
-                <a:gridCol w="2163472"/>
-              </a:tblGrid>
-              <a:tr h="384048">
-                <a:tc>
-                  <a:txBody>
-                    <a:bodyPr/>
-                    <a:lstStyle/>
-                    <a:p>
-                      <a:r>
-                        <a:rPr sz="1100" b="1">
-                          <a:solidFill>
-                            <a:srgbClr val="FFFFFF"/>
-                          </a:solidFill>
-                          <a:latin typeface="Arial"/>
-                        </a:rPr>
-                        <a:t>Bereich</a:t>
-                      </a:r>
-                    </a:p>
-                  </a:txBody>
-                  <a:tcPr>
-                    <a:solidFill>
-                      <a:srgbClr val="1F2C56"/>
-                    </a:solidFill>
-                  </a:tcPr>
-                </a:tc>
-                <a:tc>
-                  <a:txBody>
-                    <a:bodyPr/>
-                    <a:lstStyle/>
-                    <a:p>
-                      <a:r>
-                        <a:rPr sz="1100" b="1">
-                          <a:solidFill>
-                            <a:srgbClr val="FFFFFF"/>
-                          </a:solidFill>
-                          <a:latin typeface="Arial"/>
-                        </a:rPr>
-                        <a:t>Meine wichtigsten Kontakte</a:t>
-                      </a:r>
-                    </a:p>
-                  </a:txBody>
-                  <a:tcPr>
-                    <a:solidFill>
-                      <a:srgbClr val="1F2C56"/>
-                    </a:solidFill>
-                  </a:tcPr>
-                </a:tc>
-                <a:tc>
-                  <a:txBody>
-                    <a:bodyPr/>
-                    <a:lstStyle/>
-                    <a:p>
-                      <a:r>
-                        <a:rPr sz="1100" b="1">
-                          <a:solidFill>
-                            <a:srgbClr val="FFFFFF"/>
-                          </a:solidFill>
-                          <a:latin typeface="Arial"/>
-                        </a:rPr>
-                        <a:t>Qualität (1–5)</a:t>
-                      </a:r>
-                    </a:p>
-                  </a:txBody>
-                  <a:tcPr>
-                    <a:solidFill>
-                      <a:srgbClr val="1F2C56"/>
-                    </a:solidFill>
-                  </a:tcPr>
-                </a:tc>
-                <a:tc>
-                  <a:txBody>
-                    <a:bodyPr/>
-                    <a:lstStyle/>
-                    <a:p>
-                      <a:r>
-                        <a:rPr sz="1100" b="1">
-                          <a:solidFill>
-                            <a:srgbClr val="FFFFFF"/>
-                          </a:solidFill>
-                          <a:latin typeface="Arial"/>
-                        </a:rPr>
-                        <a:t>Letzte Interaktion</a:t>
-                      </a:r>
-                    </a:p>
-                  </a:txBody>
-                  <a:tcPr>
-                    <a:solidFill>
-                      <a:srgbClr val="1F2C56"/>
-                    </a:solidFill>
-                  </a:tcPr>
-                </a:tc>
-                <a:tc>
-                  <a:txBody>
-                    <a:bodyPr/>
-                    <a:lstStyle/>
-                    <a:p>
-                      <a:r>
-                        <a:rPr sz="1100" b="1">
-                          <a:solidFill>
-                            <a:srgbClr val="FFFFFF"/>
-                          </a:solidFill>
-                          <a:latin typeface="Arial"/>
-                        </a:rPr>
-                        <a:t>Nächster Schritt</a:t>
-                      </a:r>
-                    </a:p>
-                  </a:txBody>
-                  <a:tcPr>
-                    <a:solidFill>
-                      <a:srgbClr val="1F2C56"/>
-                    </a:solidFill>
-                  </a:tcPr>
-                </a:tc>
-              </a:tr>
-              <a:tr h="384048">
-                <a:tc>
-                  <a:txBody>
-                    <a:bodyPr/>
-                    <a:lstStyle/>
-                    <a:p>
-                      <a:r>
-                        <a:rPr sz="1050">
-                          <a:solidFill>
-                            <a:srgbClr val="3D5466"/>
-                          </a:solidFill>
-                          <a:latin typeface="Arial"/>
-                        </a:rPr>
-                        <a:t>Internes FK-Team</a:t>
-                      </a:r>
-                    </a:p>
-                  </a:txBody>
-                  <a:tcPr/>
-                </a:tc>
-                <a:tc>
-                  <a:txBody>
-                    <a:bodyPr/>
-                    <a:lstStyle/>
-                    <a:p/>
-                  </a:txBody>
-                  <a:tcPr/>
-                </a:tc>
-                <a:tc>
-                  <a:txBody>
-                    <a:bodyPr/>
-                    <a:lstStyle/>
-                    <a:p/>
-                  </a:txBody>
-                  <a:tcPr/>
-                </a:tc>
-                <a:tc>
-                  <a:txBody>
-                    <a:bodyPr/>
-                    <a:lstStyle/>
-                    <a:p/>
-                  </a:txBody>
-                  <a:tcPr/>
-                </a:tc>
-                <a:tc>
-                  <a:txBody>
-                    <a:bodyPr/>
-                    <a:lstStyle/>
-                    <a:p/>
-                  </a:txBody>
-                  <a:tcPr/>
-                </a:tc>
-              </a:tr>
-              <a:tr h="384048">
-                <a:tc>
-                  <a:txBody>
-                    <a:bodyPr/>
-                    <a:lstStyle/>
-                    <a:p>
-                      <a:r>
-                        <a:rPr sz="1050">
-                          <a:solidFill>
-                            <a:srgbClr val="3D5466"/>
-                          </a:solidFill>
-                          <a:latin typeface="Arial"/>
-                        </a:rPr>
-                        <a:t>Interne Spezialisten</a:t>
-                      </a:r>
-                    </a:p>
-                  </a:txBody>
-                  <a:tcPr/>
-                </a:tc>
-                <a:tc>
-                  <a:txBody>
-                    <a:bodyPr/>
-                    <a:lstStyle/>
-                    <a:p/>
-                  </a:txBody>
-                  <a:tcPr/>
-                </a:tc>
-                <a:tc>
-                  <a:txBody>
-                    <a:bodyPr/>
-                    <a:lstStyle/>
-                    <a:p/>
-                  </a:txBody>
-                  <a:tcPr/>
-                </a:tc>
-                <a:tc>
-                  <a:txBody>
-                    <a:bodyPr/>
-                    <a:lstStyle/>
-                    <a:p/>
-                  </a:txBody>
-                  <a:tcPr/>
-                </a:tc>
-                <a:tc>
-                  <a:txBody>
-                    <a:bodyPr/>
-                    <a:lstStyle/>
-                    <a:p/>
-                  </a:txBody>
-                  <a:tcPr/>
-                </a:tc>
-              </a:tr>
-              <a:tr h="384048">
-                <a:tc>
-                  <a:txBody>
-                    <a:bodyPr/>
-                    <a:lstStyle/>
-                    <a:p>
-                      <a:r>
-                        <a:rPr sz="1050">
-                          <a:solidFill>
-                            <a:srgbClr val="3D5466"/>
-                          </a:solidFill>
-                          <a:latin typeface="Arial"/>
-                        </a:rPr>
-                        <a:t>Verbundpartner</a:t>
-                      </a:r>
-                    </a:p>
-                  </a:txBody>
-                  <a:tcPr/>
-                </a:tc>
-                <a:tc>
-                  <a:txBody>
-                    <a:bodyPr/>
-                    <a:lstStyle/>
-                    <a:p/>
-                  </a:txBody>
-                  <a:tcPr/>
-                </a:tc>
-                <a:tc>
-                  <a:txBody>
-                    <a:bodyPr/>
-                    <a:lstStyle/>
-                    <a:p/>
-                  </a:txBody>
-                  <a:tcPr/>
-                </a:tc>
-                <a:tc>
-                  <a:txBody>
-                    <a:bodyPr/>
-                    <a:lstStyle/>
-                    <a:p/>
-                  </a:txBody>
-                  <a:tcPr/>
-                </a:tc>
-                <a:tc>
-                  <a:txBody>
-                    <a:bodyPr/>
-                    <a:lstStyle/>
-                    <a:p/>
-                  </a:txBody>
-                  <a:tcPr/>
-                </a:tc>
-              </a:tr>
-              <a:tr h="384048">
-                <a:tc>
-                  <a:txBody>
-                    <a:bodyPr/>
-                    <a:lstStyle/>
-                    <a:p>
-                      <a:r>
-                        <a:rPr sz="1050">
-                          <a:solidFill>
-                            <a:srgbClr val="3D5466"/>
-                          </a:solidFill>
-                          <a:latin typeface="Arial"/>
-                        </a:rPr>
-                        <a:t>Steuerberater / WP</a:t>
-                      </a:r>
-                    </a:p>
-                  </a:txBody>
-                  <a:tcPr/>
-                </a:tc>
-                <a:tc>
-                  <a:txBody>
-                    <a:bodyPr/>
-                    <a:lstStyle/>
-                    <a:p/>
-                  </a:txBody>
-                  <a:tcPr/>
-                </a:tc>
-                <a:tc>
-                  <a:txBody>
-                    <a:bodyPr/>
-                    <a:lstStyle/>
-                    <a:p/>
-                  </a:txBody>
-                  <a:tcPr/>
-                </a:tc>
-                <a:tc>
-                  <a:txBody>
-                    <a:bodyPr/>
-                    <a:lstStyle/>
-                    <a:p/>
-                  </a:txBody>
-                  <a:tcPr/>
-                </a:tc>
-                <a:tc>
-                  <a:txBody>
-                    <a:bodyPr/>
-                    <a:lstStyle/>
-                    <a:p/>
-                  </a:txBody>
-                  <a:tcPr/>
-                </a:tc>
-              </a:tr>
-              <a:tr h="384048">
-                <a:tc>
-                  <a:txBody>
-                    <a:bodyPr/>
-                    <a:lstStyle/>
-                    <a:p>
-                      <a:r>
-                        <a:rPr sz="1050">
-                          <a:solidFill>
-                            <a:srgbClr val="3D5466"/>
-                          </a:solidFill>
-                          <a:latin typeface="Arial"/>
-                        </a:rPr>
-                        <a:t>Rechtsanwälte</a:t>
-                      </a:r>
-                    </a:p>
-                  </a:txBody>
-                  <a:tcPr/>
-                </a:tc>
-                <a:tc>
-                  <a:txBody>
-                    <a:bodyPr/>
-                    <a:lstStyle/>
-                    <a:p/>
-                  </a:txBody>
-                  <a:tcPr/>
-                </a:tc>
-                <a:tc>
-                  <a:txBody>
-                    <a:bodyPr/>
-                    <a:lstStyle/>
-                    <a:p/>
-                  </a:txBody>
-                  <a:tcPr/>
-                </a:tc>
-                <a:tc>
-                  <a:txBody>
-                    <a:bodyPr/>
-                    <a:lstStyle/>
-                    <a:p/>
-                  </a:txBody>
-                  <a:tcPr/>
-                </a:tc>
-                <a:tc>
-                  <a:txBody>
-                    <a:bodyPr/>
-                    <a:lstStyle/>
-                    <a:p/>
-                  </a:txBody>
-                  <a:tcPr/>
-                </a:tc>
-              </a:tr>
-              <a:tr h="384048">
-                <a:tc>
-                  <a:txBody>
-                    <a:bodyPr/>
-                    <a:lstStyle/>
-                    <a:p>
-                      <a:r>
-                        <a:rPr sz="1050">
-                          <a:solidFill>
-                            <a:srgbClr val="3D5466"/>
-                          </a:solidFill>
-                          <a:latin typeface="Arial"/>
-                        </a:rPr>
-                        <a:t>Branchenverbände</a:t>
-                      </a:r>
-                    </a:p>
-                  </a:txBody>
-                  <a:tcPr/>
-                </a:tc>
-                <a:tc>
-                  <a:txBody>
-                    <a:bodyPr/>
-                    <a:lstStyle/>
-                    <a:p/>
-                  </a:txBody>
-                  <a:tcPr/>
-                </a:tc>
-                <a:tc>
-                  <a:txBody>
-                    <a:bodyPr/>
-                    <a:lstStyle/>
-                    <a:p/>
-                  </a:txBody>
-                  <a:tcPr/>
-                </a:tc>
-                <a:tc>
-                  <a:txBody>
-                    <a:bodyPr/>
-                    <a:lstStyle/>
-                    <a:p/>
-                  </a:txBody>
-                  <a:tcPr/>
-                </a:tc>
-                <a:tc>
-                  <a:txBody>
-                    <a:bodyPr/>
-                    <a:lstStyle/>
-                    <a:p/>
-                  </a:txBody>
-                  <a:tcPr/>
-                </a:tc>
-              </a:tr>
-              <a:tr h="384048">
-                <a:tc>
-                  <a:txBody>
-                    <a:bodyPr/>
-                    <a:lstStyle/>
-                    <a:p>
-                      <a:r>
-                        <a:rPr sz="1050">
-                          <a:solidFill>
-                            <a:srgbClr val="3D5466"/>
-                          </a:solidFill>
-                          <a:latin typeface="Arial"/>
-                        </a:rPr>
-                        <a:t>Unternehmerclubs / Gremien</a:t>
-                      </a:r>
-                    </a:p>
-                  </a:txBody>
-                  <a:tcPr/>
-                </a:tc>
-                <a:tc>
-                  <a:txBody>
-                    <a:bodyPr/>
-                    <a:lstStyle/>
-                    <a:p/>
-                  </a:txBody>
-                  <a:tcPr/>
-                </a:tc>
-                <a:tc>
-                  <a:txBody>
-                    <a:bodyPr/>
-                    <a:lstStyle/>
-                    <a:p/>
-                  </a:txBody>
-                  <a:tcPr/>
-                </a:tc>
-                <a:tc>
-                  <a:txBody>
-                    <a:bodyPr/>
-                    <a:lstStyle/>
-                    <a:p/>
-                  </a:txBody>
-                  <a:tcPr/>
-                </a:tc>
-                <a:tc>
-                  <a:txBody>
-                    <a:bodyPr/>
-                    <a:lstStyle/>
-                    <a:p/>
-                  </a:txBody>
-                  <a:tcPr/>
-                </a:tc>
-              </a:tr>
-              <a:tr h="384048">
-                <a:tc>
-                  <a:txBody>
-                    <a:bodyPr/>
-                    <a:lstStyle/>
-                    <a:p>
-                      <a:r>
-                        <a:rPr sz="1050">
-                          <a:solidFill>
-                            <a:srgbClr val="3D5466"/>
-                          </a:solidFill>
-                          <a:latin typeface="Arial"/>
-                        </a:rPr>
-                        <a:t>Digitale Kontakte</a:t>
-                      </a:r>
-                    </a:p>
-                  </a:txBody>
-                  <a:tcPr/>
-                </a:tc>
-                <a:tc>
-                  <a:txBody>
-                    <a:bodyPr/>
-                    <a:lstStyle/>
-                    <a:p/>
-                  </a:txBody>
-                  <a:tcPr/>
-                </a:tc>
-                <a:tc>
-                  <a:txBody>
-                    <a:bodyPr/>
-                    <a:lstStyle/>
-                    <a:p/>
-                  </a:txBody>
-                  <a:tcPr/>
-                </a:tc>
-                <a:tc>
-                  <a:txBody>
-                    <a:bodyPr/>
-                    <a:lstStyle/>
-                    <a:p/>
-                  </a:txBody>
-                  <a:tcPr/>
-                </a:tc>
-                <a:tc>
-                  <a:txBody>
-                    <a:bodyPr/>
-                    <a:lstStyle/>
-                    <a:p/>
-                  </a:txBody>
-                  <a:tcPr/>
-                </a:tc>
-              </a:tr>
-            </a:tbl>
-          </a:graphicData>
-        </a:graphic>
-      </p:graphicFrame>
-      <p:sp>
-        <p:nvSpPr>
-          <p:cNvPr id="8" name="Rectangle 7"/>
-          <p:cNvSpPr/>
-          <p:nvPr/>
-        </p:nvSpPr>
-        <p:spPr>
-          <a:xfrm>
-            <a:off x="0" y="6510528"/>
-            <a:ext cx="12188952" cy="347472"/>
-          </a:xfrm>
-          <a:prstGeom prst="rect">
-            <a:avLst/>
-          </a:prstGeom>
-          <a:solidFill>
-            <a:srgbClr val="0A1937"/>
-          </a:solidFill>
-          <a:ln>
-            <a:noFill/>
-          </a:ln>
-        </p:spPr>
-        <p:style>
-          <a:lnRef idx="1">
-            <a:schemeClr val="accent1"/>
-          </a:lnRef>
-          <a:fillRef idx="3">
-            <a:schemeClr val="accent1"/>
-          </a:fillRef>
-          <a:effectRef idx="2">
-            <a:schemeClr val="accent1"/>
-          </a:effectRef>
-          <a:fontRef idx="minor">
-            <a:schemeClr val="lt1"/>
-          </a:fontRef>
-        </p:style>
-        <p:txBody>
-          <a:bodyPr rtlCol="0" anchor="ctr"/>
-          <a:lstStyle/>
-          <a:p>
-            <a:pPr algn="ctr"/>
-          </a:p>
-        </p:txBody>
-      </p:sp>
-      <p:sp>
-        <p:nvSpPr>
-          <p:cNvPr id="9" name="TextBox 8"/>
-          <p:cNvSpPr txBox="1"/>
-          <p:nvPr/>
-        </p:nvSpPr>
-        <p:spPr>
-          <a:xfrm>
-            <a:off x="685800" y="6583680"/>
-            <a:ext cx="6490411" cy="256032"/>
-          </a:xfrm>
-          <a:prstGeom prst="rect">
-            <a:avLst/>
-          </a:prstGeom>
-          <a:noFill/>
-        </p:spPr>
-        <p:txBody>
-          <a:bodyPr wrap="none">
-            <a:spAutoFit/>
-          </a:bodyPr>
-          <a:lstStyle/>
-          <a:p>
-            <a:pPr algn="l"/>
-            <a:r>
-              <a:rPr sz="700">
-                <a:solidFill>
-                  <a:srgbClr val="A0B4D2"/>
-                </a:solidFill>
-                <a:latin typeface="Consolas"/>
-              </a:rPr>
-              <a:t>FKB Campus  ·  M20</a:t>
-            </a:r>
-          </a:p>
-        </p:txBody>
-      </p:sp>
-      <p:sp>
-        <p:nvSpPr>
-          <p:cNvPr id="10" name="TextBox 9"/>
-          <p:cNvSpPr txBox="1"/>
-          <p:nvPr/>
-        </p:nvSpPr>
-        <p:spPr>
-          <a:xfrm>
-            <a:off x="7176211" y="6583680"/>
-            <a:ext cx="4326940" cy="256032"/>
-          </a:xfrm>
-          <a:prstGeom prst="rect">
-            <a:avLst/>
-          </a:prstGeom>
-          <a:noFill/>
-        </p:spPr>
-        <p:txBody>
-          <a:bodyPr wrap="none">
-            <a:spAutoFit/>
-          </a:bodyPr>
-          <a:lstStyle/>
-          <a:p>
-            <a:pPr algn="r"/>
-            <a:r>
-              <a:rPr sz="700">
-                <a:solidFill>
-                  <a:srgbClr val="A0B4D2"/>
-                </a:solidFill>
-                <a:latin typeface="Consolas"/>
-              </a:rPr>
-              <a:t>Übersicht</a:t>
-            </a:r>
-          </a:p>
-        </p:txBody>
-      </p:sp>
-    </p:spTree>
-  </p:cSld>
-  <p:clrMapOvr>
-    <a:masterClrMapping/>
-  </p:clrMapOvr>
-</p:sld>
-</file>
-
-<file path=ppt/slides/slide16.xml><?xml version="1.0" encoding="utf-8"?>
-<p:sld xmlns:a="http://schemas.openxmlformats.org/drawingml/2006/main" xmlns:p="http://schemas.openxmlformats.org/presentationml/2006/main" xmlns:r="http://schemas.openxmlformats.org/officeDocument/2006/relationships">
-  <p:cSld>
-    <p:spTree>
-      <p:nvGrpSpPr>
-        <p:cNvPr id="1" name=""/>
-        <p:cNvGrpSpPr/>
-        <p:nvPr/>
-      </p:nvGrpSpPr>
-      <p:grpSpPr/>
-      <p:sp>
-        <p:nvSpPr>
-          <p:cNvPr id="2" name="Rectangle 1"/>
-          <p:cNvSpPr/>
-          <p:nvPr/>
-        </p:nvSpPr>
-        <p:spPr>
-          <a:xfrm>
-            <a:off x="0" y="0"/>
-            <a:ext cx="12188952" cy="6858000"/>
-          </a:xfrm>
-          <a:prstGeom prst="rect">
-            <a:avLst/>
-          </a:prstGeom>
-          <a:solidFill>
-            <a:srgbClr val="FFFFFF"/>
-          </a:solidFill>
-          <a:ln>
-            <a:noFill/>
-          </a:ln>
-        </p:spPr>
-        <p:style>
-          <a:lnRef idx="1">
-            <a:schemeClr val="accent1"/>
-          </a:lnRef>
-          <a:fillRef idx="3">
-            <a:schemeClr val="accent1"/>
-          </a:fillRef>
-          <a:effectRef idx="2">
-            <a:schemeClr val="accent1"/>
-          </a:effectRef>
-          <a:fontRef idx="minor">
-            <a:schemeClr val="lt1"/>
-          </a:fontRef>
-        </p:style>
-        <p:txBody>
-          <a:bodyPr rtlCol="0" anchor="ctr"/>
-          <a:lstStyle/>
-          <a:p>
-            <a:pPr algn="ctr"/>
-          </a:p>
-        </p:txBody>
-      </p:sp>
-      <p:sp>
-        <p:nvSpPr>
-          <p:cNvPr id="3" name="Rectangle 2"/>
-          <p:cNvSpPr/>
-          <p:nvPr/>
-        </p:nvSpPr>
-        <p:spPr>
-          <a:xfrm>
-            <a:off x="0" y="0"/>
-            <a:ext cx="12188952" cy="50292"/>
-          </a:xfrm>
-          <a:prstGeom prst="rect">
-            <a:avLst/>
-          </a:prstGeom>
-          <a:solidFill>
-            <a:srgbClr val="1F2C56"/>
-          </a:solidFill>
-          <a:ln>
-            <a:noFill/>
-          </a:ln>
-        </p:spPr>
-        <p:style>
-          <a:lnRef idx="1">
-            <a:schemeClr val="accent1"/>
-          </a:lnRef>
-          <a:fillRef idx="3">
-            <a:schemeClr val="accent1"/>
-          </a:fillRef>
-          <a:effectRef idx="2">
-            <a:schemeClr val="accent1"/>
-          </a:effectRef>
-          <a:fontRef idx="minor">
-            <a:schemeClr val="lt1"/>
-          </a:fontRef>
-        </p:style>
-        <p:txBody>
-          <a:bodyPr rtlCol="0" anchor="ctr"/>
-          <a:lstStyle/>
-          <a:p>
-            <a:pPr algn="ctr"/>
-          </a:p>
-        </p:txBody>
-      </p:sp>
-      <p:sp>
-        <p:nvSpPr>
-          <p:cNvPr id="4" name="TextBox 3"/>
-          <p:cNvSpPr txBox="1"/>
-          <p:nvPr/>
-        </p:nvSpPr>
-        <p:spPr>
-          <a:xfrm>
-            <a:off x="685800" y="109728"/>
-            <a:ext cx="10817352" cy="228600"/>
-          </a:xfrm>
-          <a:prstGeom prst="rect">
-            <a:avLst/>
-          </a:prstGeom>
-          <a:noFill/>
-        </p:spPr>
-        <p:txBody>
-          <a:bodyPr wrap="none">
-            <a:spAutoFit/>
-          </a:bodyPr>
-          <a:lstStyle/>
-          <a:p>
-            <a:pPr algn="l"/>
-            <a:r>
-              <a:rPr sz="750">
-                <a:solidFill>
-                  <a:srgbClr val="78808C"/>
-                </a:solidFill>
-                <a:latin typeface="Consolas"/>
-              </a:rPr>
-              <a:t>M20  ·  ÜBERSICHT</a:t>
-            </a:r>
-          </a:p>
-        </p:txBody>
-      </p:sp>
-      <p:sp>
-        <p:nvSpPr>
-          <p:cNvPr id="5" name="TextBox 4"/>
-          <p:cNvSpPr txBox="1"/>
-          <p:nvPr/>
-        </p:nvSpPr>
-        <p:spPr>
-          <a:xfrm>
-            <a:off x="685800" y="502920"/>
-            <a:ext cx="10817352" cy="594360"/>
-          </a:xfrm>
-          <a:prstGeom prst="rect">
-            <a:avLst/>
-          </a:prstGeom>
-          <a:noFill/>
-        </p:spPr>
-        <p:txBody>
-          <a:bodyPr wrap="square">
-            <a:spAutoFit/>
-          </a:bodyPr>
-          <a:lstStyle/>
-          <a:p>
-            <a:pPr algn="l"/>
-            <a:r>
-              <a:rPr sz="2000" b="1" i="0">
-                <a:solidFill>
-                  <a:srgbClr val="1F2C56"/>
-                </a:solidFill>
-                <a:latin typeface="Arial"/>
-              </a:rPr>
-              <a:t>AB-3: 90-Tage-Aktionsplan</a:t>
-            </a:r>
-          </a:p>
-        </p:txBody>
-      </p:sp>
-      <p:sp>
-        <p:nvSpPr>
-          <p:cNvPr id="6" name="Rectangle 5"/>
-          <p:cNvSpPr/>
-          <p:nvPr/>
-        </p:nvSpPr>
-        <p:spPr>
-          <a:xfrm>
-            <a:off x="685800" y="1143000"/>
-            <a:ext cx="10817352" cy="25400"/>
-          </a:xfrm>
-          <a:prstGeom prst="rect">
-            <a:avLst/>
-          </a:prstGeom>
-          <a:solidFill>
-            <a:srgbClr val="D9C089"/>
-          </a:solidFill>
-          <a:ln>
-            <a:noFill/>
-          </a:ln>
-        </p:spPr>
-        <p:style>
-          <a:lnRef idx="1">
-            <a:schemeClr val="accent1"/>
-          </a:lnRef>
-          <a:fillRef idx="3">
-            <a:schemeClr val="accent1"/>
-          </a:fillRef>
-          <a:effectRef idx="2">
-            <a:schemeClr val="accent1"/>
-          </a:effectRef>
-          <a:fontRef idx="minor">
-            <a:schemeClr val="lt1"/>
-          </a:fontRef>
-        </p:style>
-        <p:txBody>
-          <a:bodyPr rtlCol="0" anchor="ctr"/>
-          <a:lstStyle/>
-          <a:p>
-            <a:pPr algn="ctr"/>
-          </a:p>
-        </p:txBody>
-      </p:sp>
-      <p:graphicFrame>
-        <p:nvGraphicFramePr>
-          <p:cNvPr id="7" name="Table 6"/>
-          <p:cNvGraphicFramePr>
-            <a:graphicFrameLocks noGrp="1"/>
-          </p:cNvGraphicFramePr>
-          <p:nvPr/>
-        </p:nvGraphicFramePr>
-        <p:xfrm>
-          <a:off x="685800" y="1417320"/>
-          <a:ext cx="10817352" cy="1920240"/>
-        </p:xfrm>
-        <a:graphic>
-          <a:graphicData uri="http://schemas.openxmlformats.org/drawingml/2006/table">
-            <a:tbl>
-              <a:tblPr firstRow="1" bandRow="1">
-                <a:tableStyleId>{5C22544A-7EE6-4342-B048-85BDC9FD1C3A}</a:tableStyleId>
-              </a:tblPr>
-              <a:tblGrid>
-                <a:gridCol w="2163470"/>
-                <a:gridCol w="2163470"/>
-                <a:gridCol w="2163470"/>
-                <a:gridCol w="2163470"/>
-                <a:gridCol w="2163472"/>
-              </a:tblGrid>
-              <a:tr h="384048">
-                <a:tc>
-                  <a:txBody>
-                    <a:bodyPr/>
-                    <a:lstStyle/>
-                    <a:p>
-                      <a:r>
-                        <a:rPr sz="1100" b="1">
-                          <a:solidFill>
-                            <a:srgbClr val="FFFFFF"/>
-                          </a:solidFill>
-                          <a:latin typeface="Arial"/>
-                        </a:rPr>
-                        <a:t>Zeitraum</a:t>
-                      </a:r>
-                    </a:p>
-                  </a:txBody>
-                  <a:tcPr>
-                    <a:solidFill>
-                      <a:srgbClr val="1F2C56"/>
-                    </a:solidFill>
-                  </a:tcPr>
-                </a:tc>
-                <a:tc>
-                  <a:txBody>
-                    <a:bodyPr/>
-                    <a:lstStyle/>
-                    <a:p>
-                      <a:r>
-                        <a:rPr sz="1100" b="1">
-                          <a:solidFill>
-                            <a:srgbClr val="FFFFFF"/>
-                          </a:solidFill>
-                          <a:latin typeface="Arial"/>
-                        </a:rPr>
-                        <a:t>Aktivität</a:t>
-                      </a:r>
-                    </a:p>
-                  </a:txBody>
-                  <a:tcPr>
-                    <a:solidFill>
-                      <a:srgbClr val="1F2C56"/>
-                    </a:solidFill>
-                  </a:tcPr>
-                </a:tc>
-                <a:tc>
-                  <a:txBody>
-                    <a:bodyPr/>
-                    <a:lstStyle/>
-                    <a:p>
-                      <a:r>
-                        <a:rPr sz="1100" b="1">
-                          <a:solidFill>
-                            <a:srgbClr val="FFFFFF"/>
-                          </a:solidFill>
-                          <a:latin typeface="Arial"/>
-                        </a:rPr>
-                        <a:t>Zielkontakt</a:t>
-                      </a:r>
-                    </a:p>
-                  </a:txBody>
-                  <a:tcPr>
-                    <a:solidFill>
-                      <a:srgbClr val="1F2C56"/>
-                    </a:solidFill>
-                  </a:tcPr>
-                </a:tc>
-                <a:tc>
-                  <a:txBody>
-                    <a:bodyPr/>
-                    <a:lstStyle/>
-                    <a:p>
-                      <a:r>
-                        <a:rPr sz="1100" b="1">
-                          <a:solidFill>
-                            <a:srgbClr val="FFFFFF"/>
-                          </a:solidFill>
-                          <a:latin typeface="Arial"/>
-                        </a:rPr>
-                        <a:t>Ziel</a:t>
-                      </a:r>
-                    </a:p>
-                  </a:txBody>
-                  <a:tcPr>
-                    <a:solidFill>
-                      <a:srgbClr val="1F2C56"/>
-                    </a:solidFill>
-                  </a:tcPr>
-                </a:tc>
-                <a:tc>
-                  <a:txBody>
-                    <a:bodyPr/>
-                    <a:lstStyle/>
-                    <a:p>
-                      <a:r>
-                        <a:rPr sz="1100" b="1">
-                          <a:solidFill>
-                            <a:srgbClr val="FFFFFF"/>
-                          </a:solidFill>
-                          <a:latin typeface="Arial"/>
-                        </a:rPr>
-                        <a:t>Erledigt?</a:t>
-                      </a:r>
-                    </a:p>
-                  </a:txBody>
-                  <a:tcPr>
-                    <a:solidFill>
-                      <a:srgbClr val="1F2C56"/>
-                    </a:solidFill>
-                  </a:tcPr>
-                </a:tc>
-              </a:tr>
-              <a:tr h="384048">
-                <a:tc>
-                  <a:txBody>
-                    <a:bodyPr/>
-                    <a:lstStyle/>
-                    <a:p>
-                      <a:r>
-                        <a:rPr sz="1050">
-                          <a:solidFill>
-                            <a:srgbClr val="3D5466"/>
-                          </a:solidFill>
-                          <a:latin typeface="Arial"/>
-                        </a:rPr>
-                        <a:t>Woche 1–2</a:t>
-                      </a:r>
-                    </a:p>
-                  </a:txBody>
-                  <a:tcPr/>
-                </a:tc>
-                <a:tc>
-                  <a:txBody>
-                    <a:bodyPr/>
-                    <a:lstStyle/>
-                    <a:p/>
-                  </a:txBody>
-                  <a:tcPr/>
-                </a:tc>
-                <a:tc>
-                  <a:txBody>
-                    <a:bodyPr/>
-                    <a:lstStyle/>
-                    <a:p/>
-                  </a:txBody>
-                  <a:tcPr/>
-                </a:tc>
-                <a:tc>
-                  <a:txBody>
-                    <a:bodyPr/>
-                    <a:lstStyle/>
-                    <a:p/>
-                  </a:txBody>
-                  <a:tcPr/>
-                </a:tc>
-                <a:tc>
-                  <a:txBody>
-                    <a:bodyPr/>
-                    <a:lstStyle/>
-                    <a:p/>
-                  </a:txBody>
-                  <a:tcPr/>
-                </a:tc>
-              </a:tr>
-              <a:tr h="384048">
-                <a:tc>
-                  <a:txBody>
-                    <a:bodyPr/>
-                    <a:lstStyle/>
-                    <a:p>
-                      <a:r>
-                        <a:rPr sz="1050">
-                          <a:solidFill>
-                            <a:srgbClr val="3D5466"/>
-                          </a:solidFill>
-                          <a:latin typeface="Arial"/>
-                        </a:rPr>
-                        <a:t>Woche 3–4</a:t>
-                      </a:r>
-                    </a:p>
-                  </a:txBody>
-                  <a:tcPr/>
-                </a:tc>
-                <a:tc>
-                  <a:txBody>
-                    <a:bodyPr/>
-                    <a:lstStyle/>
-                    <a:p/>
-                  </a:txBody>
-                  <a:tcPr/>
-                </a:tc>
-                <a:tc>
-                  <a:txBody>
-                    <a:bodyPr/>
-                    <a:lstStyle/>
-                    <a:p/>
-                  </a:txBody>
-                  <a:tcPr/>
-                </a:tc>
-                <a:tc>
-                  <a:txBody>
-                    <a:bodyPr/>
-                    <a:lstStyle/>
-                    <a:p/>
-                  </a:txBody>
-                  <a:tcPr/>
-                </a:tc>
-                <a:tc>
-                  <a:txBody>
-                    <a:bodyPr/>
-                    <a:lstStyle/>
-                    <a:p/>
-                  </a:txBody>
-                  <a:tcPr/>
-                </a:tc>
-              </a:tr>
-              <a:tr h="384048">
-                <a:tc>
-                  <a:txBody>
-                    <a:bodyPr/>
-                    <a:lstStyle/>
-                    <a:p>
-                      <a:r>
-                        <a:rPr sz="1050">
-                          <a:solidFill>
-                            <a:srgbClr val="3D5466"/>
-                          </a:solidFill>
-                          <a:latin typeface="Arial"/>
-                        </a:rPr>
-                        <a:t>Monat 2</a:t>
-                      </a:r>
-                    </a:p>
-                  </a:txBody>
-                  <a:tcPr/>
-                </a:tc>
-                <a:tc>
-                  <a:txBody>
-                    <a:bodyPr/>
-                    <a:lstStyle/>
-                    <a:p/>
-                  </a:txBody>
-                  <a:tcPr/>
-                </a:tc>
-                <a:tc>
-                  <a:txBody>
-                    <a:bodyPr/>
-                    <a:lstStyle/>
-                    <a:p/>
-                  </a:txBody>
-                  <a:tcPr/>
-                </a:tc>
-                <a:tc>
-                  <a:txBody>
-                    <a:bodyPr/>
-                    <a:lstStyle/>
-                    <a:p/>
-                  </a:txBody>
-                  <a:tcPr/>
-                </a:tc>
-                <a:tc>
-                  <a:txBody>
-                    <a:bodyPr/>
-                    <a:lstStyle/>
-                    <a:p/>
-                  </a:txBody>
-                  <a:tcPr/>
-                </a:tc>
-              </a:tr>
-              <a:tr h="384048">
-                <a:tc>
-                  <a:txBody>
-                    <a:bodyPr/>
-                    <a:lstStyle/>
-                    <a:p>
-                      <a:r>
-                        <a:rPr sz="1050">
-                          <a:solidFill>
-                            <a:srgbClr val="3D5466"/>
-                          </a:solidFill>
-                          <a:latin typeface="Arial"/>
-                        </a:rPr>
-                        <a:t>Monat 3</a:t>
-                      </a:r>
-                    </a:p>
-                  </a:txBody>
-                  <a:tcPr/>
-                </a:tc>
-                <a:tc>
-                  <a:txBody>
-                    <a:bodyPr/>
-                    <a:lstStyle/>
-                    <a:p/>
-                  </a:txBody>
-                  <a:tcPr/>
-                </a:tc>
-                <a:tc>
-                  <a:txBody>
-                    <a:bodyPr/>
-                    <a:lstStyle/>
-                    <a:p/>
-                  </a:txBody>
-                  <a:tcPr/>
-                </a:tc>
-                <a:tc>
-                  <a:txBody>
-                    <a:bodyPr/>
-                    <a:lstStyle/>
-                    <a:p/>
-                  </a:txBody>
-                  <a:tcPr/>
-                </a:tc>
-                <a:tc>
-                  <a:txBody>
-                    <a:bodyPr/>
-                    <a:lstStyle/>
-                    <a:p/>
-                  </a:txBody>
-                  <a:tcPr/>
-                </a:tc>
-              </a:tr>
-            </a:tbl>
-          </a:graphicData>
-        </a:graphic>
-      </p:graphicFrame>
-      <p:sp>
-        <p:nvSpPr>
-          <p:cNvPr id="8" name="Rectangle 7"/>
-          <p:cNvSpPr/>
-          <p:nvPr/>
-        </p:nvSpPr>
-        <p:spPr>
-          <a:xfrm>
-            <a:off x="0" y="6510528"/>
-            <a:ext cx="12188952" cy="347472"/>
-          </a:xfrm>
-          <a:prstGeom prst="rect">
-            <a:avLst/>
-          </a:prstGeom>
-          <a:solidFill>
-            <a:srgbClr val="0A1937"/>
-          </a:solidFill>
-          <a:ln>
-            <a:noFill/>
-          </a:ln>
-        </p:spPr>
-        <p:style>
-          <a:lnRef idx="1">
-            <a:schemeClr val="accent1"/>
-          </a:lnRef>
-          <a:fillRef idx="3">
-            <a:schemeClr val="accent1"/>
-          </a:fillRef>
-          <a:effectRef idx="2">
-            <a:schemeClr val="accent1"/>
-          </a:effectRef>
-          <a:fontRef idx="minor">
-            <a:schemeClr val="lt1"/>
-          </a:fontRef>
-        </p:style>
-        <p:txBody>
-          <a:bodyPr rtlCol="0" anchor="ctr"/>
-          <a:lstStyle/>
-          <a:p>
-            <a:pPr algn="ctr"/>
-          </a:p>
-        </p:txBody>
-      </p:sp>
-      <p:sp>
-        <p:nvSpPr>
-          <p:cNvPr id="9" name="TextBox 8"/>
-          <p:cNvSpPr txBox="1"/>
-          <p:nvPr/>
-        </p:nvSpPr>
-        <p:spPr>
-          <a:xfrm>
-            <a:off x="685800" y="6583680"/>
-            <a:ext cx="6490411" cy="256032"/>
-          </a:xfrm>
-          <a:prstGeom prst="rect">
-            <a:avLst/>
-          </a:prstGeom>
-          <a:noFill/>
-        </p:spPr>
-        <p:txBody>
-          <a:bodyPr wrap="none">
-            <a:spAutoFit/>
-          </a:bodyPr>
-          <a:lstStyle/>
-          <a:p>
-            <a:pPr algn="l"/>
-            <a:r>
-              <a:rPr sz="700">
-                <a:solidFill>
-                  <a:srgbClr val="A0B4D2"/>
-                </a:solidFill>
-                <a:latin typeface="Consolas"/>
-              </a:rPr>
-              <a:t>FKB Campus  ·  M20</a:t>
-            </a:r>
-          </a:p>
-        </p:txBody>
-      </p:sp>
-      <p:sp>
-        <p:nvSpPr>
-          <p:cNvPr id="10" name="TextBox 9"/>
-          <p:cNvSpPr txBox="1"/>
-          <p:nvPr/>
-        </p:nvSpPr>
-        <p:spPr>
-          <a:xfrm>
-            <a:off x="7176211" y="6583680"/>
-            <a:ext cx="4326940" cy="256032"/>
-          </a:xfrm>
-          <a:prstGeom prst="rect">
-            <a:avLst/>
-          </a:prstGeom>
-          <a:noFill/>
-        </p:spPr>
-        <p:txBody>
-          <a:bodyPr wrap="none">
-            <a:spAutoFit/>
-          </a:bodyPr>
-          <a:lstStyle/>
-          <a:p>
-            <a:pPr algn="r"/>
-            <a:r>
-              <a:rPr sz="700">
-                <a:solidFill>
-                  <a:srgbClr val="A0B4D2"/>
-                </a:solidFill>
-                <a:latin typeface="Consolas"/>
-              </a:rPr>
-              <a:t>Übersicht</a:t>
             </a:r>
           </a:p>
         </p:txBody>
@@ -10250,7 +8280,7 @@
                 </a:solidFill>
                 <a:latin typeface="Arial"/>
               </a:rPr>
-              <a:t>Dimension 1: Internes Netzwerk</a:t>
+              <a:t>Beziehungen baut man, bevor man sie braucht</a:t>
             </a:r>
           </a:p>
         </p:txBody>
@@ -10276,6 +8306,25 @@
             <a:spAutoFit/>
           </a:bodyPr>
           <a:lstStyle/>
+          <a:p>
+            <a:pPr marL="177800" indent="-177800">
+              <a:spcBef>
+                <a:spcPts val="600"/>
+              </a:spcBef>
+              <a:spcAft>
+                <a:spcPts val="200"/>
+              </a:spcAft>
+            </a:pPr>
+            <a:r>
+              <a:rPr sz="1200" i="1">
+                <a:solidFill>
+                  <a:srgbClr val="3D5466"/>
+                </a:solidFill>
+                <a:latin typeface="Arial"/>
+              </a:rPr>
+              <a:t>→  Beziehungen baut man, bevor man sie braucht.</a:t>
+            </a:r>
+          </a:p>
           <a:p>
             <a:pPr marL="190500" indent="-190500">
               <a:spcBef>
@@ -10292,7 +8341,7 @@
                 </a:solidFill>
                 <a:latin typeface="Arial"/>
               </a:rPr>
-              <a:t>▸  Die häufig unterschätzte Dimension. Wer im eigenen Haus als kompetenter Ansprechpartner bekannt ist, bekommt:</a:t>
+              <a:t>▸  Ein Netzwerk aus Brücken (nicht nur Kontakten) bringt Anfragen, bevor der Wettbewerb sie sieht.</a:t>
             </a:r>
           </a:p>
           <a:p>
@@ -10311,64 +8360,7 @@
                 </a:solidFill>
                 <a:latin typeface="Arial"/>
               </a:rPr>
-              <a:t>▸  Interne Empfehlungen aus Privatkundenbereichen</a:t>
-            </a:r>
-          </a:p>
-          <a:p>
-            <a:pPr marL="190500" indent="-190500">
-              <a:spcBef>
-                <a:spcPts val="400"/>
-              </a:spcBef>
-              <a:spcAft>
-                <a:spcPts val="200"/>
-              </a:spcAft>
-            </a:pPr>
-            <a:r>
-              <a:rPr sz="1300">
-                <a:solidFill>
-                  <a:srgbClr val="3D5466"/>
-                </a:solidFill>
-                <a:latin typeface="Arial"/>
-              </a:rPr>
-              <a:t>▸  Frühzeitige Informationen über anstehende Regulierungen oder Strategieänderungen</a:t>
-            </a:r>
-          </a:p>
-          <a:p>
-            <a:pPr marL="190500" indent="-190500">
-              <a:spcBef>
-                <a:spcPts val="400"/>
-              </a:spcBef>
-              <a:spcAft>
-                <a:spcPts val="200"/>
-              </a:spcAft>
-            </a:pPr>
-            <a:r>
-              <a:rPr sz="1300">
-                <a:solidFill>
-                  <a:srgbClr val="3D5466"/>
-                </a:solidFill>
-                <a:latin typeface="Arial"/>
-              </a:rPr>
-              <a:t>▸  Unterstützung bei komplexen Fällen durch Spezialisten (Immobilien, Strukturierte Finanzierung, Ausland)</a:t>
-            </a:r>
-          </a:p>
-          <a:p>
-            <a:pPr marL="190500" indent="-190500">
-              <a:spcBef>
-                <a:spcPts val="400"/>
-              </a:spcBef>
-              <a:spcAft>
-                <a:spcPts val="200"/>
-              </a:spcAft>
-            </a:pPr>
-            <a:r>
-              <a:rPr sz="1300">
-                <a:solidFill>
-                  <a:srgbClr val="3D5466"/>
-                </a:solidFill>
-                <a:latin typeface="Arial"/>
-              </a:rPr>
-              <a:t>▸  Netzwerkanker intern: Bereichsleiter FK, Kreditspezialisten, Risikomanager, Privatkundenberater mit Unternehmerkunden, Verbundpartner-Spezialisten (R+V, Union Investment).</a:t>
+              <a:t>▸  Netzwerk und Sichtbarkeit sind keine Selbstvermarktung, sondern professionelle Marktbearbeitung.</a:t>
             </a:r>
           </a:p>
         </p:txBody>
@@ -10706,7 +8698,7 @@
                 </a:solidFill>
                 <a:latin typeface="Arial"/>
               </a:rPr>
-              <a:t>Dimension 2: Verbundpartner-Netzwerk</a:t>
+              <a:t>Drei Netzwerkdimensionen eines FK-Beraters</a:t>
             </a:r>
           </a:p>
         </p:txBody>
@@ -10732,6 +8724,25 @@
             <a:spAutoFit/>
           </a:bodyPr>
           <a:lstStyle/>
+          <a:p>
+            <a:pPr marL="177800" indent="-177800">
+              <a:spcBef>
+                <a:spcPts val="600"/>
+              </a:spcBef>
+              <a:spcAft>
+                <a:spcPts val="200"/>
+              </a:spcAft>
+            </a:pPr>
+            <a:r>
+              <a:rPr sz="1200" i="1">
+                <a:solidFill>
+                  <a:srgbClr val="3D5466"/>
+                </a:solidFill>
+                <a:latin typeface="Arial"/>
+              </a:rPr>
+              <a:t>→  Ein tragfähiges Netzwerk hat drei Dimensionen – wer nur eine pflegt, steht auf einem Bein.</a:t>
+            </a:r>
+          </a:p>
           <a:p>
             <a:pPr marL="190500" indent="-190500">
               <a:spcBef>
@@ -10748,7 +8759,7 @@
                 </a:solidFill>
                 <a:latin typeface="Arial"/>
               </a:rPr>
-              <a:t>▸  Strategischer Nutzen: Verbundpartner können den Berater bei ihren eigenen Kundenkontakten empfehlen; der Berater positioniert sich als Koordinator der gesamten Verbundleistung.</a:t>
+              <a:t>▸  Internes Netzwerk: Marktfolge, Verbund-Ansprechpartner, Teamleitung.</a:t>
             </a:r>
           </a:p>
           <a:p>
@@ -10767,7 +8778,7 @@
                 </a:solidFill>
                 <a:latin typeface="Arial"/>
               </a:rPr>
-              <a:t>▸  Konkrete Formate, die in der Praxis funktionieren:</a:t>
+              <a:t>▸  Verbundpartner-Netzwerk: R+V, Union Investment, DZ BANK, Bausparkasse.</a:t>
             </a:r>
           </a:p>
           <a:p>
@@ -10786,45 +8797,7 @@
                 </a:solidFill>
                 <a:latin typeface="Arial"/>
               </a:rPr>
-              <a:t>▸  Gemeinsame Kundenveranstaltungen mit R+V oder Union Investment: Der FK-Berater tritt als Co-Moderator auf und gewinnt Sichtbarkeit bei Kunden anderer Berater.</a:t>
-            </a:r>
-          </a:p>
-          <a:p>
-            <a:pPr marL="190500" indent="-190500">
-              <a:spcBef>
-                <a:spcPts val="400"/>
-              </a:spcBef>
-              <a:spcAft>
-                <a:spcPts val="200"/>
-              </a:spcAft>
-            </a:pPr>
-            <a:r>
-              <a:rPr sz="1300">
-                <a:solidFill>
-                  <a:srgbClr val="3D5466"/>
-                </a:solidFill>
-                <a:latin typeface="Arial"/>
-              </a:rPr>
-              <a:t>▸  Monatlicher Jour fixe (30 Min.) mit dem R+V-Gebietsleiter oder UIN-Regionalbetreuer: Leads gegenseitig teilen, aktuelle Cross-Selling-Opportunitäten besprechen.</a:t>
-            </a:r>
-          </a:p>
-          <a:p>
-            <a:pPr marL="190500" indent="-190500">
-              <a:spcBef>
-                <a:spcPts val="400"/>
-              </a:spcBef>
-              <a:spcAft>
-                <a:spcPts val="200"/>
-              </a:spcAft>
-            </a:pPr>
-            <a:r>
-              <a:rPr sz="1300">
-                <a:solidFill>
-                  <a:srgbClr val="3D5466"/>
-                </a:solidFill>
-                <a:latin typeface="Arial"/>
-              </a:rPr>
-              <a:t>▸  Internes Cross-Selling-Meeting: Privatkundenberater mit Unternehmerkunden systematisch ansprechen – das ist im Alltag oft der schnellste Weg zu Neukunden, wird aber selten als aktives Format geführt.</a:t>
+              <a:t>▸  Markt-Netzwerk: Steuerberater, Kammern, Multiplikatoren, Bestandskunden.</a:t>
             </a:r>
           </a:p>
         </p:txBody>
@@ -10940,7 +8913,7 @@
             <a:avLst/>
           </a:prstGeom>
           <a:solidFill>
-            <a:srgbClr val="EDEDF3"/>
+            <a:srgbClr val="FFFFFF"/>
           </a:solidFill>
           <a:ln>
             <a:noFill/>
@@ -11041,51 +9014,43 @@
                 </a:solidFill>
                 <a:latin typeface="Consolas"/>
               </a:rPr>
-              <a:t>M20  ·  INHALT</a:t>
-            </a:r>
-          </a:p>
-        </p:txBody>
-      </p:sp>
-      <p:sp>
-        <p:nvSpPr>
-          <p:cNvPr id="5" name="Rectangle 4"/>
-          <p:cNvSpPr/>
-          <p:nvPr/>
-        </p:nvSpPr>
-        <p:spPr>
-          <a:xfrm>
-            <a:off x="0" y="1234440"/>
-            <a:ext cx="12188952" cy="12700"/>
-          </a:xfrm>
-          <a:prstGeom prst="rect">
-            <a:avLst/>
-          </a:prstGeom>
-          <a:solidFill>
-            <a:srgbClr val="D8DFE4"/>
-          </a:solidFill>
-          <a:ln>
-            <a:noFill/>
-          </a:ln>
-        </p:spPr>
-        <p:style>
-          <a:lnRef idx="1">
-            <a:schemeClr val="accent1"/>
-          </a:lnRef>
-          <a:fillRef idx="3">
-            <a:schemeClr val="accent1"/>
-          </a:fillRef>
-          <a:effectRef idx="2">
-            <a:schemeClr val="accent1"/>
-          </a:effectRef>
-          <a:fontRef idx="minor">
-            <a:schemeClr val="lt1"/>
-          </a:fontRef>
-        </p:style>
-        <p:txBody>
-          <a:bodyPr rtlCol="0" anchor="ctr"/>
-          <a:lstStyle/>
-          <a:p>
-            <a:pPr algn="ctr"/>
+              <a:t>M20  ·  SCHAUBILD</a:t>
+            </a:r>
+          </a:p>
+        </p:txBody>
+      </p:sp>
+      <p:sp>
+        <p:nvSpPr>
+          <p:cNvPr id="5" name="TextBox 4"/>
+          <p:cNvSpPr txBox="1"/>
+          <p:nvPr/>
+        </p:nvSpPr>
+        <p:spPr>
+          <a:xfrm>
+            <a:off x="685800" y="502920"/>
+            <a:ext cx="10817352" cy="594360"/>
+          </a:xfrm>
+          <a:prstGeom prst="rect">
+            <a:avLst/>
+          </a:prstGeom>
+          <a:noFill/>
+        </p:spPr>
+        <p:txBody>
+          <a:bodyPr wrap="square">
+            <a:spAutoFit/>
+          </a:bodyPr>
+          <a:lstStyle/>
+          <a:p>
+            <a:pPr algn="l"/>
+            <a:r>
+              <a:rPr sz="2000" b="1" i="0">
+                <a:solidFill>
+                  <a:srgbClr val="1F2C56"/>
+                </a:solidFill>
+                <a:latin typeface="Arial"/>
+              </a:rPr>
+              <a:t>Die drei Netzwerk-Dimensionen eines FK-Beraters</a:t>
+            </a:r>
           </a:p>
         </p:txBody>
       </p:sp>
@@ -11097,8 +9062,8 @@
         </p:nvSpPr>
         <p:spPr>
           <a:xfrm>
-            <a:off x="685800" y="502920"/>
-            <a:ext cx="36576" cy="658368"/>
+            <a:off x="685800" y="1143000"/>
+            <a:ext cx="10817352" cy="25400"/>
           </a:xfrm>
           <a:prstGeom prst="rect">
             <a:avLst/>
@@ -11132,105 +9097,33 @@
           </a:p>
         </p:txBody>
       </p:sp>
-      <p:sp>
-        <p:nvSpPr>
-          <p:cNvPr id="7" name="TextBox 6"/>
-          <p:cNvSpPr txBox="1"/>
-          <p:nvPr/>
-        </p:nvSpPr>
-        <p:spPr>
-          <a:xfrm>
-            <a:off x="813816" y="502920"/>
-            <a:ext cx="10634472" cy="685800"/>
-          </a:xfrm>
-          <a:prstGeom prst="rect">
-            <a:avLst/>
-          </a:prstGeom>
-          <a:noFill/>
-        </p:spPr>
-        <p:txBody>
-          <a:bodyPr wrap="square">
-            <a:spAutoFit/>
-          </a:bodyPr>
-          <a:lstStyle/>
-          <a:p>
-            <a:pPr algn="l"/>
-            <a:r>
-              <a:rPr sz="2400" b="1" i="0">
-                <a:solidFill>
-                  <a:srgbClr val="1F2C56"/>
-                </a:solidFill>
-                <a:latin typeface="Arial"/>
-              </a:rPr>
-              <a:t>Dimension 3: Markt-Netzwerk</a:t>
-            </a:r>
-          </a:p>
-        </p:txBody>
-      </p:sp>
-      <p:sp>
-        <p:nvSpPr>
-          <p:cNvPr id="8" name="TextBox 7"/>
-          <p:cNvSpPr txBox="1"/>
-          <p:nvPr/>
-        </p:nvSpPr>
-        <p:spPr>
-          <a:xfrm>
-            <a:off x="685800" y="1417320"/>
-            <a:ext cx="10817352" cy="4892040"/>
-          </a:xfrm>
-          <a:prstGeom prst="rect">
-            <a:avLst/>
-          </a:prstGeom>
-          <a:noFill/>
-        </p:spPr>
-        <p:txBody>
-          <a:bodyPr wrap="square" anchor="ctr">
-            <a:spAutoFit/>
-          </a:bodyPr>
-          <a:lstStyle/>
-          <a:p>
-            <a:pPr marL="190500" indent="-190500">
-              <a:spcBef>
-                <a:spcPts val="400"/>
-              </a:spcBef>
-              <a:spcAft>
-                <a:spcPts val="200"/>
-              </a:spcAft>
-            </a:pPr>
-            <a:r>
-              <a:rPr sz="1300">
-                <a:solidFill>
-                  <a:srgbClr val="3D5466"/>
-                </a:solidFill>
-                <a:latin typeface="Arial"/>
-              </a:rPr>
-              <a:t>▸  ## 4.3 Netzwerkanalyse: Den eigenen Status realistisch einschätzen</a:t>
-            </a:r>
-          </a:p>
-          <a:p>
-            <a:pPr marL="190500" indent="-190500">
-              <a:spcBef>
-                <a:spcPts val="400"/>
-              </a:spcBef>
-              <a:spcAft>
-                <a:spcPts val="200"/>
-              </a:spcAft>
-            </a:pPr>
-            <a:r>
-              <a:rPr sz="1300">
-                <a:solidFill>
-                  <a:srgbClr val="3D5466"/>
-                </a:solidFill>
-                <a:latin typeface="Arial"/>
-              </a:rPr>
-              <a:t>▸  Vor jeder Netzwerkstrategie steht die Analyse. Nicht: „Wie viele Kontakte habe ich?" – sondern: „Welche Verbindungen fehlen mir für meine Ziele?"</a:t>
-            </a:r>
-          </a:p>
-        </p:txBody>
-      </p:sp>
-      <p:sp>
-        <p:nvSpPr>
-          <p:cNvPr id="9" name="Rectangle 8"/>
+      <p:pic>
+        <p:nvPicPr>
+          <p:cNvPr id="7" name="Picture 6" descr="image.png"/>
+          <p:cNvPicPr>
+            <a:picLocks noChangeAspect="1"/>
+          </p:cNvPicPr>
+          <p:nvPr/>
+        </p:nvPicPr>
+        <p:blipFill>
+          <a:blip r:embed="rId2"/>
+          <a:stretch>
+            <a:fillRect/>
+          </a:stretch>
+        </p:blipFill>
+        <p:spPr>
+          <a:xfrm>
+            <a:off x="2303489" y="1325880"/>
+            <a:ext cx="7581973" cy="4937760"/>
+          </a:xfrm>
+          <a:prstGeom prst="rect">
+            <a:avLst/>
+          </a:prstGeom>
+        </p:spPr>
+      </p:pic>
+      <p:sp>
+        <p:nvSpPr>
+          <p:cNvPr id="8" name="Rectangle 7"/>
           <p:cNvSpPr/>
           <p:nvPr/>
         </p:nvSpPr>
@@ -11273,7 +9166,7 @@
       </p:sp>
       <p:sp>
         <p:nvSpPr>
-          <p:cNvPr id="10" name="TextBox 9"/>
+          <p:cNvPr id="9" name="TextBox 8"/>
           <p:cNvSpPr txBox="1"/>
           <p:nvPr/>
         </p:nvSpPr>
@@ -11302,6 +9195,41 @@
                 <a:latin typeface="Consolas"/>
               </a:rPr>
               <a:t>FKB Campus  ·  M20</a:t>
+            </a:r>
+          </a:p>
+        </p:txBody>
+      </p:sp>
+      <p:sp>
+        <p:nvSpPr>
+          <p:cNvPr id="10" name="TextBox 9"/>
+          <p:cNvSpPr txBox="1"/>
+          <p:nvPr/>
+        </p:nvSpPr>
+        <p:spPr>
+          <a:xfrm>
+            <a:off x="7176211" y="6583680"/>
+            <a:ext cx="4326940" cy="256032"/>
+          </a:xfrm>
+          <a:prstGeom prst="rect">
+            <a:avLst/>
+          </a:prstGeom>
+          <a:noFill/>
+        </p:spPr>
+        <p:txBody>
+          <a:bodyPr wrap="none">
+            <a:spAutoFit/>
+          </a:bodyPr>
+          <a:lstStyle/>
+          <a:p>
+            <a:pPr algn="r"/>
+            <a:r>
+              <a:rPr sz="700">
+                <a:solidFill>
+                  <a:srgbClr val="A0B4D2"/>
+                </a:solidFill>
+                <a:latin typeface="Consolas"/>
+              </a:rPr>
+              <a:t>Schaubild</a:t>
             </a:r>
           </a:p>
         </p:txBody>
@@ -11339,7 +9267,7 @@
             <a:avLst/>
           </a:prstGeom>
           <a:solidFill>
-            <a:srgbClr val="FFFFFF"/>
+            <a:srgbClr val="EDEDF3"/>
           </a:solidFill>
           <a:ln>
             <a:noFill/>
@@ -11440,43 +9368,51 @@
                 </a:solidFill>
                 <a:latin typeface="Consolas"/>
               </a:rPr>
-              <a:t>M20  ·  SCHAUBILD</a:t>
-            </a:r>
-          </a:p>
-        </p:txBody>
-      </p:sp>
-      <p:sp>
-        <p:nvSpPr>
-          <p:cNvPr id="5" name="TextBox 4"/>
-          <p:cNvSpPr txBox="1"/>
-          <p:nvPr/>
-        </p:nvSpPr>
-        <p:spPr>
-          <a:xfrm>
-            <a:off x="685800" y="502920"/>
-            <a:ext cx="10817352" cy="594360"/>
-          </a:xfrm>
-          <a:prstGeom prst="rect">
-            <a:avLst/>
-          </a:prstGeom>
-          <a:noFill/>
-        </p:spPr>
-        <p:txBody>
-          <a:bodyPr wrap="square">
-            <a:spAutoFit/>
-          </a:bodyPr>
-          <a:lstStyle/>
-          <a:p>
-            <a:pPr algn="l"/>
-            <a:r>
-              <a:rPr sz="2000" b="1" i="0">
-                <a:solidFill>
-                  <a:srgbClr val="1F2C56"/>
-                </a:solidFill>
-                <a:latin typeface="Arial"/>
-              </a:rPr>
-              <a:t>Netzwerk-Dimensionen eines FK-Beraters</a:t>
-            </a:r>
+              <a:t>M20  ·  INHALT</a:t>
+            </a:r>
+          </a:p>
+        </p:txBody>
+      </p:sp>
+      <p:sp>
+        <p:nvSpPr>
+          <p:cNvPr id="5" name="Rectangle 4"/>
+          <p:cNvSpPr/>
+          <p:nvPr/>
+        </p:nvSpPr>
+        <p:spPr>
+          <a:xfrm>
+            <a:off x="0" y="1234440"/>
+            <a:ext cx="12188952" cy="12700"/>
+          </a:xfrm>
+          <a:prstGeom prst="rect">
+            <a:avLst/>
+          </a:prstGeom>
+          <a:solidFill>
+            <a:srgbClr val="D8DFE4"/>
+          </a:solidFill>
+          <a:ln>
+            <a:noFill/>
+          </a:ln>
+        </p:spPr>
+        <p:style>
+          <a:lnRef idx="1">
+            <a:schemeClr val="accent1"/>
+          </a:lnRef>
+          <a:fillRef idx="3">
+            <a:schemeClr val="accent1"/>
+          </a:fillRef>
+          <a:effectRef idx="2">
+            <a:schemeClr val="accent1"/>
+          </a:effectRef>
+          <a:fontRef idx="minor">
+            <a:schemeClr val="lt1"/>
+          </a:fontRef>
+        </p:style>
+        <p:txBody>
+          <a:bodyPr rtlCol="0" anchor="ctr"/>
+          <a:lstStyle/>
+          <a:p>
+            <a:pPr algn="ctr"/>
           </a:p>
         </p:txBody>
       </p:sp>
@@ -11488,8 +9424,8 @@
         </p:nvSpPr>
         <p:spPr>
           <a:xfrm>
-            <a:off x="685800" y="1143000"/>
-            <a:ext cx="10817352" cy="25400"/>
+            <a:off x="685800" y="502920"/>
+            <a:ext cx="36576" cy="658368"/>
           </a:xfrm>
           <a:prstGeom prst="rect">
             <a:avLst/>
@@ -11523,33 +9459,143 @@
           </a:p>
         </p:txBody>
       </p:sp>
-      <p:pic>
-        <p:nvPicPr>
-          <p:cNvPr id="7" name="Picture 6" descr="image.png"/>
-          <p:cNvPicPr>
-            <a:picLocks noChangeAspect="1"/>
-          </p:cNvPicPr>
-          <p:nvPr/>
-        </p:nvPicPr>
-        <p:blipFill>
-          <a:blip r:embed="rId2"/>
-          <a:stretch>
-            <a:fillRect/>
-          </a:stretch>
-        </p:blipFill>
-        <p:spPr>
-          <a:xfrm>
-            <a:off x="2303489" y="1325880"/>
-            <a:ext cx="7581973" cy="4937760"/>
-          </a:xfrm>
-          <a:prstGeom prst="rect">
-            <a:avLst/>
-          </a:prstGeom>
-        </p:spPr>
-      </p:pic>
-      <p:sp>
-        <p:nvSpPr>
-          <p:cNvPr id="8" name="Rectangle 7"/>
+      <p:sp>
+        <p:nvSpPr>
+          <p:cNvPr id="7" name="TextBox 6"/>
+          <p:cNvSpPr txBox="1"/>
+          <p:nvPr/>
+        </p:nvSpPr>
+        <p:spPr>
+          <a:xfrm>
+            <a:off x="813816" y="502920"/>
+            <a:ext cx="10634472" cy="685800"/>
+          </a:xfrm>
+          <a:prstGeom prst="rect">
+            <a:avLst/>
+          </a:prstGeom>
+          <a:noFill/>
+        </p:spPr>
+        <p:txBody>
+          <a:bodyPr wrap="square">
+            <a:spAutoFit/>
+          </a:bodyPr>
+          <a:lstStyle/>
+          <a:p>
+            <a:pPr algn="l"/>
+            <a:r>
+              <a:rPr sz="2400" b="1" i="0">
+                <a:solidFill>
+                  <a:srgbClr val="1F2C56"/>
+                </a:solidFill>
+                <a:latin typeface="Arial"/>
+              </a:rPr>
+              <a:t>Das Netzwerk-Audit: drei ehrliche Fragen</a:t>
+            </a:r>
+          </a:p>
+        </p:txBody>
+      </p:sp>
+      <p:sp>
+        <p:nvSpPr>
+          <p:cNvPr id="8" name="TextBox 7"/>
+          <p:cNvSpPr txBox="1"/>
+          <p:nvPr/>
+        </p:nvSpPr>
+        <p:spPr>
+          <a:xfrm>
+            <a:off x="685800" y="1417320"/>
+            <a:ext cx="10817352" cy="4892040"/>
+          </a:xfrm>
+          <a:prstGeom prst="rect">
+            <a:avLst/>
+          </a:prstGeom>
+          <a:noFill/>
+        </p:spPr>
+        <p:txBody>
+          <a:bodyPr wrap="square" anchor="ctr">
+            <a:spAutoFit/>
+          </a:bodyPr>
+          <a:lstStyle/>
+          <a:p>
+            <a:pPr marL="177800" indent="-177800">
+              <a:spcBef>
+                <a:spcPts val="600"/>
+              </a:spcBef>
+              <a:spcAft>
+                <a:spcPts val="200"/>
+              </a:spcAft>
+            </a:pPr>
+            <a:r>
+              <a:rPr sz="1200" i="1">
+                <a:solidFill>
+                  <a:srgbClr val="3D5466"/>
+                </a:solidFill>
+                <a:latin typeface="Arial"/>
+              </a:rPr>
+              <a:t>→  Bevor man baut, misst man – das Netzwerk-Audit zeigt schonungslos, wo Brücken fehlen.</a:t>
+            </a:r>
+          </a:p>
+          <a:p>
+            <a:pPr marL="190500" indent="-190500">
+              <a:spcBef>
+                <a:spcPts val="400"/>
+              </a:spcBef>
+              <a:spcAft>
+                <a:spcPts val="200"/>
+              </a:spcAft>
+            </a:pPr>
+            <a:r>
+              <a:rPr sz="1300">
+                <a:solidFill>
+                  <a:srgbClr val="3D5466"/>
+                </a:solidFill>
+                <a:latin typeface="Arial"/>
+              </a:rPr>
+              <a:t>▸  Wen kenne ich – und wer kennt mich als Experten?</a:t>
+            </a:r>
+          </a:p>
+          <a:p>
+            <a:pPr marL="190500" indent="-190500">
+              <a:spcBef>
+                <a:spcPts val="400"/>
+              </a:spcBef>
+              <a:spcAft>
+                <a:spcPts val="200"/>
+              </a:spcAft>
+            </a:pPr>
+            <a:r>
+              <a:rPr sz="1300">
+                <a:solidFill>
+                  <a:srgbClr val="3D5466"/>
+                </a:solidFill>
+                <a:latin typeface="Arial"/>
+              </a:rPr>
+              <a:t>▸  Welche Dimension ist unterentwickelt?</a:t>
+            </a:r>
+          </a:p>
+          <a:p>
+            <a:pPr marL="190500" indent="-190500">
+              <a:spcBef>
+                <a:spcPts val="400"/>
+              </a:spcBef>
+              <a:spcAft>
+                <a:spcPts val="200"/>
+              </a:spcAft>
+            </a:pPr>
+            <a:r>
+              <a:rPr sz="1300">
+                <a:solidFill>
+                  <a:srgbClr val="3D5466"/>
+                </a:solidFill>
+                <a:latin typeface="Arial"/>
+              </a:rPr>
+              <a:t>▸  Welche drei Brücken fehlen mir für mein Zielsegment?</a:t>
+            </a:r>
+          </a:p>
+        </p:txBody>
+      </p:sp>
+      <p:sp>
+        <p:nvSpPr>
+          <p:cNvPr id="9" name="Rectangle 8"/>
           <p:cNvSpPr/>
           <p:nvPr/>
         </p:nvSpPr>
@@ -11592,7 +9638,7 @@
       </p:sp>
       <p:sp>
         <p:nvSpPr>
-          <p:cNvPr id="9" name="TextBox 8"/>
+          <p:cNvPr id="10" name="TextBox 9"/>
           <p:cNvSpPr txBox="1"/>
           <p:nvPr/>
         </p:nvSpPr>
@@ -11621,41 +9667,6 @@
                 <a:latin typeface="Consolas"/>
               </a:rPr>
               <a:t>FKB Campus  ·  M20</a:t>
-            </a:r>
-          </a:p>
-        </p:txBody>
-      </p:sp>
-      <p:sp>
-        <p:nvSpPr>
-          <p:cNvPr id="10" name="TextBox 9"/>
-          <p:cNvSpPr txBox="1"/>
-          <p:nvPr/>
-        </p:nvSpPr>
-        <p:spPr>
-          <a:xfrm>
-            <a:off x="7176211" y="6583680"/>
-            <a:ext cx="4326940" cy="256032"/>
-          </a:xfrm>
-          <a:prstGeom prst="rect">
-            <a:avLst/>
-          </a:prstGeom>
-          <a:noFill/>
-        </p:spPr>
-        <p:txBody>
-          <a:bodyPr wrap="none">
-            <a:spAutoFit/>
-          </a:bodyPr>
-          <a:lstStyle/>
-          <a:p>
-            <a:pPr algn="r"/>
-            <a:r>
-              <a:rPr sz="700">
-                <a:solidFill>
-                  <a:srgbClr val="A0B4D2"/>
-                </a:solidFill>
-                <a:latin typeface="Consolas"/>
-              </a:rPr>
-              <a:t>Schaubild</a:t>
             </a:r>
           </a:p>
         </p:txBody>
@@ -11693,7 +9704,7 @@
             <a:avLst/>
           </a:prstGeom>
           <a:solidFill>
-            <a:srgbClr val="EDEDF3"/>
+            <a:srgbClr val="1F2C56"/>
           </a:solidFill>
           <a:ln>
             <a:noFill/>
@@ -11723,57 +9734,14 @@
       </p:sp>
       <p:sp>
         <p:nvSpPr>
-          <p:cNvPr id="3" name="Rectangle 2"/>
-          <p:cNvSpPr/>
-          <p:nvPr/>
-        </p:nvSpPr>
-        <p:spPr>
-          <a:xfrm>
-            <a:off x="0" y="0"/>
-            <a:ext cx="12188952" cy="50292"/>
-          </a:xfrm>
-          <a:prstGeom prst="rect">
-            <a:avLst/>
-          </a:prstGeom>
-          <a:solidFill>
-            <a:srgbClr val="1F2C56"/>
-          </a:solidFill>
-          <a:ln>
-            <a:noFill/>
-          </a:ln>
-        </p:spPr>
-        <p:style>
-          <a:lnRef idx="1">
-            <a:schemeClr val="accent1"/>
-          </a:lnRef>
-          <a:fillRef idx="3">
-            <a:schemeClr val="accent1"/>
-          </a:fillRef>
-          <a:effectRef idx="2">
-            <a:schemeClr val="accent1"/>
-          </a:effectRef>
-          <a:fontRef idx="minor">
-            <a:schemeClr val="lt1"/>
-          </a:fontRef>
-        </p:style>
-        <p:txBody>
-          <a:bodyPr rtlCol="0" anchor="ctr"/>
-          <a:lstStyle/>
-          <a:p>
-            <a:pPr algn="ctr"/>
-          </a:p>
-        </p:txBody>
-      </p:sp>
-      <p:sp>
-        <p:nvSpPr>
-          <p:cNvPr id="4" name="TextBox 3"/>
+          <p:cNvPr id="3" name="TextBox 2"/>
           <p:cNvSpPr txBox="1"/>
           <p:nvPr/>
         </p:nvSpPr>
         <p:spPr>
           <a:xfrm>
-            <a:off x="685800" y="109728"/>
-            <a:ext cx="10817352" cy="228600"/>
+            <a:off x="685800" y="2377440"/>
+            <a:ext cx="10817352" cy="365760"/>
           </a:xfrm>
           <a:prstGeom prst="rect">
             <a:avLst/>
@@ -11788,70 +9756,27 @@
           <a:p>
             <a:pPr algn="l"/>
             <a:r>
-              <a:rPr sz="750">
-                <a:solidFill>
-                  <a:srgbClr val="78808C"/>
+              <a:rPr sz="1200">
+                <a:solidFill>
+                  <a:srgbClr val="D9C089"/>
                 </a:solidFill>
                 <a:latin typeface="Consolas"/>
               </a:rPr>
-              <a:t>M20  ·  INHALT</a:t>
-            </a:r>
-          </a:p>
-        </p:txBody>
-      </p:sp>
-      <p:sp>
-        <p:nvSpPr>
-          <p:cNvPr id="5" name="Rectangle 4"/>
+              <a:t>FORMATE</a:t>
+            </a:r>
+          </a:p>
+        </p:txBody>
+      </p:sp>
+      <p:sp>
+        <p:nvSpPr>
+          <p:cNvPr id="4" name="Rectangle 3"/>
           <p:cNvSpPr/>
           <p:nvPr/>
         </p:nvSpPr>
         <p:spPr>
           <a:xfrm>
-            <a:off x="0" y="1234440"/>
-            <a:ext cx="12188952" cy="12700"/>
-          </a:xfrm>
-          <a:prstGeom prst="rect">
-            <a:avLst/>
-          </a:prstGeom>
-          <a:solidFill>
-            <a:srgbClr val="D8DFE4"/>
-          </a:solidFill>
-          <a:ln>
-            <a:noFill/>
-          </a:ln>
-        </p:spPr>
-        <p:style>
-          <a:lnRef idx="1">
-            <a:schemeClr val="accent1"/>
-          </a:lnRef>
-          <a:fillRef idx="3">
-            <a:schemeClr val="accent1"/>
-          </a:fillRef>
-          <a:effectRef idx="2">
-            <a:schemeClr val="accent1"/>
-          </a:effectRef>
-          <a:fontRef idx="minor">
-            <a:schemeClr val="lt1"/>
-          </a:fontRef>
-        </p:style>
-        <p:txBody>
-          <a:bodyPr rtlCol="0" anchor="ctr"/>
-          <a:lstStyle/>
-          <a:p>
-            <a:pPr algn="ctr"/>
-          </a:p>
-        </p:txBody>
-      </p:sp>
-      <p:sp>
-        <p:nvSpPr>
-          <p:cNvPr id="6" name="Rectangle 5"/>
-          <p:cNvSpPr/>
-          <p:nvPr/>
-        </p:nvSpPr>
-        <p:spPr>
-          <a:xfrm>
-            <a:off x="685800" y="502920"/>
-            <a:ext cx="36576" cy="658368"/>
+            <a:off x="685800" y="2788920"/>
+            <a:ext cx="548640" cy="38100"/>
           </a:xfrm>
           <a:prstGeom prst="rect">
             <a:avLst/>
@@ -11887,14 +9812,14 @@
       </p:sp>
       <p:sp>
         <p:nvSpPr>
-          <p:cNvPr id="7" name="TextBox 6"/>
+          <p:cNvPr id="5" name="TextBox 4"/>
           <p:cNvSpPr txBox="1"/>
           <p:nvPr/>
         </p:nvSpPr>
         <p:spPr>
           <a:xfrm>
-            <a:off x="813816" y="502920"/>
-            <a:ext cx="10634472" cy="685800"/>
+            <a:off x="685800" y="3017520"/>
+            <a:ext cx="10817352" cy="1463040"/>
           </a:xfrm>
           <a:prstGeom prst="rect">
             <a:avLst/>
@@ -11909,27 +9834,27 @@
           <a:p>
             <a:pPr algn="l"/>
             <a:r>
-              <a:rPr sz="2400" b="1" i="0">
-                <a:solidFill>
-                  <a:srgbClr val="1F2C56"/>
+              <a:rPr sz="4000" b="1" i="0">
+                <a:solidFill>
+                  <a:srgbClr val="FFFFFF"/>
                 </a:solidFill>
                 <a:latin typeface="Arial"/>
               </a:rPr>
-              <a:t>Das Netzwerk-Audit (3 Fragen)</a:t>
-            </a:r>
-          </a:p>
-        </p:txBody>
-      </p:sp>
-      <p:sp>
-        <p:nvSpPr>
-          <p:cNvPr id="8" name="TextBox 7"/>
+              <a:t>Sichtbarkeit ohne Eigenwerbung</a:t>
+            </a:r>
+          </a:p>
+        </p:txBody>
+      </p:sp>
+      <p:sp>
+        <p:nvSpPr>
+          <p:cNvPr id="6" name="TextBox 5"/>
           <p:cNvSpPr txBox="1"/>
           <p:nvPr/>
         </p:nvSpPr>
         <p:spPr>
           <a:xfrm>
-            <a:off x="685800" y="1417320"/>
-            <a:ext cx="10817352" cy="4892040"/>
+            <a:off x="685800" y="4480560"/>
+            <a:ext cx="8653881" cy="1280160"/>
           </a:xfrm>
           <a:prstGeom prst="rect">
             <a:avLst/>
@@ -11942,250 +9867,29 @@
           </a:bodyPr>
           <a:lstStyle/>
           <a:p>
-            <a:pPr marL="190500" indent="-190500">
-              <a:spcBef>
-                <a:spcPts val="400"/>
-              </a:spcBef>
-              <a:spcAft>
-                <a:spcPts val="200"/>
-              </a:spcAft>
-            </a:pPr>
-            <a:r>
-              <a:rPr sz="1300">
-                <a:solidFill>
-                  <a:srgbClr val="3D5466"/>
+            <a:pPr algn="l"/>
+            <a:r>
+              <a:rPr sz="1600" b="0" i="0">
+                <a:solidFill>
+                  <a:srgbClr val="C8D2E6"/>
                 </a:solidFill>
                 <a:latin typeface="Arial"/>
               </a:rPr>
-              <a:t>▸  Frage 1: Stärke meiner bestehenden Verbindungen</a:t>
-            </a:r>
-          </a:p>
-          <a:p>
-            <a:pPr marL="190500" indent="-190500">
-              <a:spcBef>
-                <a:spcPts val="400"/>
-              </a:spcBef>
-              <a:spcAft>
-                <a:spcPts val="200"/>
-              </a:spcAft>
-            </a:pPr>
-            <a:r>
-              <a:rPr sz="1300">
-                <a:solidFill>
-                  <a:srgbClr val="3D5466"/>
-                </a:solidFill>
-                <a:latin typeface="Arial"/>
-              </a:rPr>
-              <a:t>▸  Frage 2: Wo sind meine strukturellen Lücken?</a:t>
-            </a:r>
-          </a:p>
-          <a:p>
-            <a:pPr marL="190500" indent="-190500">
-              <a:spcBef>
-                <a:spcPts val="400"/>
-              </a:spcBef>
-              <a:spcAft>
-                <a:spcPts val="200"/>
-              </a:spcAft>
-            </a:pPr>
-            <a:r>
-              <a:rPr sz="1300">
-                <a:solidFill>
-                  <a:srgbClr val="3D5466"/>
-                </a:solidFill>
-                <a:latin typeface="Arial"/>
-              </a:rPr>
-              <a:t>▸  In welchen Branchen kenne ich niemanden außer meinen eigenen Kunden?</a:t>
-            </a:r>
-          </a:p>
-          <a:p>
-            <a:pPr marL="190500" indent="-190500">
-              <a:spcBef>
-                <a:spcPts val="400"/>
-              </a:spcBef>
-              <a:spcAft>
-                <a:spcPts val="200"/>
-              </a:spcAft>
-            </a:pPr>
-            <a:r>
-              <a:rPr sz="1300">
-                <a:solidFill>
-                  <a:srgbClr val="3D5466"/>
-                </a:solidFill>
-                <a:latin typeface="Arial"/>
-              </a:rPr>
-              <a:t>▸  Mit welchen Multiplikatoren hätte ich gerne Kontakt, aber noch keinen?</a:t>
-            </a:r>
-          </a:p>
-          <a:p>
-            <a:pPr marL="190500" indent="-190500">
-              <a:spcBef>
-                <a:spcPts val="400"/>
-              </a:spcBef>
-              <a:spcAft>
-                <a:spcPts val="200"/>
-              </a:spcAft>
-            </a:pPr>
-            <a:r>
-              <a:rPr sz="1300">
-                <a:solidFill>
-                  <a:srgbClr val="3D5466"/>
-                </a:solidFill>
-                <a:latin typeface="Arial"/>
-              </a:rPr>
-              <a:t>▸  Welche internen Bereiche kenne ich zu wenig?</a:t>
-            </a:r>
-          </a:p>
-          <a:p>
-            <a:pPr marL="190500" indent="-190500">
-              <a:spcBef>
-                <a:spcPts val="400"/>
-              </a:spcBef>
-              <a:spcAft>
-                <a:spcPts val="200"/>
-              </a:spcAft>
-            </a:pPr>
-            <a:r>
-              <a:rPr sz="1300">
-                <a:solidFill>
-                  <a:srgbClr val="3D5466"/>
-                </a:solidFill>
-                <a:latin typeface="Arial"/>
-              </a:rPr>
-              <a:t>▸  Frage 3: Wo liegt mein Broker-Potenzial?</a:t>
-            </a:r>
-          </a:p>
-          <a:p>
-            <a:pPr marL="190500" indent="-190500">
-              <a:spcBef>
-                <a:spcPts val="400"/>
-              </a:spcBef>
-              <a:spcAft>
-                <a:spcPts val="200"/>
-              </a:spcAft>
-            </a:pPr>
-            <a:r>
-              <a:rPr sz="1300">
-                <a:solidFill>
-                  <a:srgbClr val="3D5466"/>
-                </a:solidFill>
-                <a:latin typeface="Arial"/>
-              </a:rPr>
-              <a:t>▸  Welche zwei Gruppen in meinem Netzwerk kennen sich nicht, würden aber voneinander profitieren?</a:t>
-            </a:r>
-          </a:p>
-          <a:p>
-            <a:pPr marL="190500" indent="-190500">
-              <a:spcBef>
-                <a:spcPts val="400"/>
-              </a:spcBef>
-              <a:spcAft>
-                <a:spcPts val="200"/>
-              </a:spcAft>
-            </a:pPr>
-            <a:r>
-              <a:rPr sz="1300">
-                <a:solidFill>
-                  <a:srgbClr val="3D5466"/>
-                </a:solidFill>
-                <a:latin typeface="Arial"/>
-              </a:rPr>
-              <a:t>▸  Wo kann ich durch Zusammenführen Mehrwert stiften – ohne Eigeninteresse?</a:t>
-            </a:r>
-          </a:p>
-          <a:p>
-            <a:pPr marL="190500" indent="-190500">
-              <a:spcBef>
-                <a:spcPts val="400"/>
-              </a:spcBef>
-              <a:spcAft>
-                <a:spcPts val="200"/>
-              </a:spcAft>
-            </a:pPr>
-            <a:r>
-              <a:rPr sz="1300">
-                <a:solidFill>
-                  <a:srgbClr val="3D5466"/>
-                </a:solidFill>
-                <a:latin typeface="Arial"/>
-              </a:rPr>
-              <a:t>▸  ## 4.4 Sichtbarkeit: Expertise sichtbar machen ohne Eigenwerbung</a:t>
-            </a:r>
-          </a:p>
-          <a:p>
-            <a:pPr marL="190500" indent="-190500">
-              <a:spcBef>
-                <a:spcPts val="400"/>
-              </a:spcBef>
-              <a:spcAft>
-                <a:spcPts val="200"/>
-              </a:spcAft>
-            </a:pPr>
-            <a:r>
-              <a:rPr sz="1300">
-                <a:solidFill>
-                  <a:srgbClr val="3D5466"/>
-                </a:solidFill>
-                <a:latin typeface="Arial"/>
-              </a:rPr>
-              <a:t>▸  Sichtbarkeit entsteht nicht durch Selbstlob, sondern durch konsistente Fachkompetenz, die anderen nutzt. Die wirkmächtigsten Formate:</a:t>
-            </a:r>
-          </a:p>
-        </p:txBody>
-      </p:sp>
-      <p:sp>
-        <p:nvSpPr>
-          <p:cNvPr id="9" name="Rectangle 8"/>
-          <p:cNvSpPr/>
-          <p:nvPr/>
-        </p:nvSpPr>
-        <p:spPr>
-          <a:xfrm>
-            <a:off x="0" y="6510528"/>
-            <a:ext cx="12188952" cy="347472"/>
-          </a:xfrm>
-          <a:prstGeom prst="rect">
-            <a:avLst/>
-          </a:prstGeom>
-          <a:solidFill>
-            <a:srgbClr val="0A1937"/>
-          </a:solidFill>
-          <a:ln>
-            <a:noFill/>
-          </a:ln>
-        </p:spPr>
-        <p:style>
-          <a:lnRef idx="1">
-            <a:schemeClr val="accent1"/>
-          </a:lnRef>
-          <a:fillRef idx="3">
-            <a:schemeClr val="accent1"/>
-          </a:fillRef>
-          <a:effectRef idx="2">
-            <a:schemeClr val="accent1"/>
-          </a:effectRef>
-          <a:fontRef idx="minor">
-            <a:schemeClr val="lt1"/>
-          </a:fontRef>
-        </p:style>
-        <p:txBody>
-          <a:bodyPr rtlCol="0" anchor="ctr"/>
-          <a:lstStyle/>
-          <a:p>
-            <a:pPr algn="ctr"/>
-          </a:p>
-        </p:txBody>
-      </p:sp>
-      <p:sp>
-        <p:nvSpPr>
-          <p:cNvPr id="10" name="TextBox 9"/>
+              <a:t>Expertise sichtbar machen, ohne sich anzupreisen.</a:t>
+            </a:r>
+          </a:p>
+        </p:txBody>
+      </p:sp>
+      <p:sp>
+        <p:nvSpPr>
+          <p:cNvPr id="7" name="TextBox 6"/>
           <p:cNvSpPr txBox="1"/>
           <p:nvPr/>
         </p:nvSpPr>
         <p:spPr>
           <a:xfrm>
-            <a:off x="685800" y="6583680"/>
-            <a:ext cx="6490411" cy="256032"/>
+            <a:off x="685800" y="6355080"/>
+            <a:ext cx="10817352" cy="274320"/>
           </a:xfrm>
           <a:prstGeom prst="rect">
             <a:avLst/>
@@ -12202,7 +9906,7 @@
             <a:r>
               <a:rPr sz="700">
                 <a:solidFill>
-                  <a:srgbClr val="A0B4D2"/>
+                  <a:srgbClr val="8CA0C3"/>
                 </a:solidFill>
                 <a:latin typeface="Consolas"/>
               </a:rPr>

</xml_diff>